<commit_message>
Add formal project report document and update team presentation with all 3 members
</commit_message>
<xml_diff>
--- a/Final_Course_Project_Review.pptx
+++ b/Final_Course_Project_Review.pptx
@@ -5,22 +5,22 @@
     <p:sldMasterId id="2147483648" r:id="rId1"/>
   </p:sldMasterIdLst>
   <p:sldIdLst>
-    <p:sldId id="256" r:id="rId2"/>
-    <p:sldId id="257" r:id="rId3"/>
-    <p:sldId id="258" r:id="rId4"/>
-    <p:sldId id="259" r:id="rId5"/>
-    <p:sldId id="260" r:id="rId6"/>
-    <p:sldId id="261" r:id="rId7"/>
-    <p:sldId id="262" r:id="rId8"/>
-    <p:sldId id="263" r:id="rId9"/>
-    <p:sldId id="264" r:id="rId10"/>
-    <p:sldId id="265" r:id="rId11"/>
-    <p:sldId id="266" r:id="rId12"/>
-    <p:sldId id="267" r:id="rId13"/>
-    <p:sldId id="268" r:id="rId14"/>
-    <p:sldId id="269" r:id="rId15"/>
+    <p:sldId id="256" r:id="rId7"/>
+    <p:sldId id="257" r:id="rId8"/>
+    <p:sldId id="258" r:id="rId9"/>
+    <p:sldId id="259" r:id="rId10"/>
+    <p:sldId id="260" r:id="rId11"/>
+    <p:sldId id="261" r:id="rId12"/>
+    <p:sldId id="262" r:id="rId13"/>
+    <p:sldId id="263" r:id="rId14"/>
+    <p:sldId id="264" r:id="rId15"/>
+    <p:sldId id="265" r:id="rId16"/>
+    <p:sldId id="266" r:id="rId17"/>
+    <p:sldId id="267" r:id="rId18"/>
+    <p:sldId id="268" r:id="rId19"/>
+    <p:sldId id="269" r:id="rId20"/>
   </p:sldIdLst>
-  <p:sldSz cx="12192000" cy="6858000"/>
+  <p:sldSz cx="12191695" cy="6858000" type="screen4x3"/>
   <p:notesSz cx="6858000" cy="9144000"/>
   <p:defaultTextStyle>
     <a:defPPr>
@@ -117,22 +117,6 @@
       </a:defRPr>
     </a:lvl9pPr>
   </p:defaultTextStyle>
-  <p:extLst>
-    <p:ext uri="{EFAFB233-063F-42B5-8137-9DF3F51BA10A}">
-      <p15:sldGuideLst xmlns:p15="http://schemas.microsoft.com/office/powerpoint/2012/main">
-        <p15:guide id="1" orient="horz" pos="2160">
-          <p15:clr>
-            <a:srgbClr val="A4A3A4"/>
-          </p15:clr>
-        </p15:guide>
-        <p15:guide id="2" pos="2880">
-          <p15:clr>
-            <a:srgbClr val="A4A3A4"/>
-          </p15:clr>
-        </p15:guide>
-      </p15:sldGuideLst>
-    </p:ext>
-  </p:extLst>
 </p:presentation>
 </file>
 
@@ -174,9 +158,10 @@
           <a:lstStyle/>
           <a:p>
             <a:r>
-              <a:rPr lang="en-US"/>
+              <a:rPr lang="en-US" smtClean="0"/>
               <a:t>Click to edit Master title style</a:t>
             </a:r>
+            <a:endParaRPr lang="en-US"/>
           </a:p>
         </p:txBody>
       </p:sp>
@@ -292,9 +277,10 @@
           </a:lstStyle>
           <a:p>
             <a:r>
-              <a:rPr lang="en-US"/>
+              <a:rPr lang="en-US" smtClean="0"/>
               <a:t>Click to edit Master subtitle style</a:t>
             </a:r>
+            <a:endParaRPr lang="en-US"/>
           </a:p>
         </p:txBody>
       </p:sp>
@@ -315,7 +301,7 @@
           <a:p>
             <a:fld id="{5BCAD085-E8A6-8845-BD4E-CB4CCA059FC4}" type="datetimeFigureOut">
               <a:rPr lang="en-US" smtClean="0"/>
-              <a:t>10/28/2026</a:t>
+              <a:t>1/27/13</a:t>
             </a:fld>
             <a:endParaRPr lang="en-US"/>
           </a:p>
@@ -409,9 +395,10 @@
           <a:lstStyle/>
           <a:p>
             <a:r>
-              <a:rPr lang="en-US"/>
+              <a:rPr lang="en-US" smtClean="0"/>
               <a:t>Click to edit Master title style</a:t>
             </a:r>
+            <a:endParaRPr lang="en-US"/>
           </a:p>
         </p:txBody>
       </p:sp>
@@ -432,37 +419,38 @@
           <a:p>
             <a:pPr lvl="0"/>
             <a:r>
-              <a:rPr lang="en-US"/>
+              <a:rPr lang="en-US" smtClean="0"/>
               <a:t>Click to edit Master text styles</a:t>
             </a:r>
           </a:p>
           <a:p>
             <a:pPr lvl="1"/>
             <a:r>
-              <a:rPr lang="en-US"/>
+              <a:rPr lang="en-US" smtClean="0"/>
               <a:t>Second level</a:t>
             </a:r>
           </a:p>
           <a:p>
             <a:pPr lvl="2"/>
             <a:r>
-              <a:rPr lang="en-US"/>
+              <a:rPr lang="en-US" smtClean="0"/>
               <a:t>Third level</a:t>
             </a:r>
           </a:p>
           <a:p>
             <a:pPr lvl="3"/>
             <a:r>
-              <a:rPr lang="en-US"/>
+              <a:rPr lang="en-US" smtClean="0"/>
               <a:t>Fourth level</a:t>
             </a:r>
           </a:p>
           <a:p>
             <a:pPr lvl="4"/>
             <a:r>
-              <a:rPr lang="en-US"/>
+              <a:rPr lang="en-US" smtClean="0"/>
               <a:t>Fifth level</a:t>
             </a:r>
+            <a:endParaRPr lang="en-US"/>
           </a:p>
         </p:txBody>
       </p:sp>
@@ -483,7 +471,7 @@
           <a:p>
             <a:fld id="{5BCAD085-E8A6-8845-BD4E-CB4CCA059FC4}" type="datetimeFigureOut">
               <a:rPr lang="en-US" smtClean="0"/>
-              <a:t>10/28/2026</a:t>
+              <a:t>1/27/13</a:t>
             </a:fld>
             <a:endParaRPr lang="en-US"/>
           </a:p>
@@ -582,9 +570,10 @@
           <a:lstStyle/>
           <a:p>
             <a:r>
-              <a:rPr lang="en-US"/>
+              <a:rPr lang="en-US" smtClean="0"/>
               <a:t>Click to edit Master title style</a:t>
             </a:r>
+            <a:endParaRPr lang="en-US"/>
           </a:p>
         </p:txBody>
       </p:sp>
@@ -610,37 +599,38 @@
           <a:p>
             <a:pPr lvl="0"/>
             <a:r>
-              <a:rPr lang="en-US"/>
+              <a:rPr lang="en-US" smtClean="0"/>
               <a:t>Click to edit Master text styles</a:t>
             </a:r>
           </a:p>
           <a:p>
             <a:pPr lvl="1"/>
             <a:r>
-              <a:rPr lang="en-US"/>
+              <a:rPr lang="en-US" smtClean="0"/>
               <a:t>Second level</a:t>
             </a:r>
           </a:p>
           <a:p>
             <a:pPr lvl="2"/>
             <a:r>
-              <a:rPr lang="en-US"/>
+              <a:rPr lang="en-US" smtClean="0"/>
               <a:t>Third level</a:t>
             </a:r>
           </a:p>
           <a:p>
             <a:pPr lvl="3"/>
             <a:r>
-              <a:rPr lang="en-US"/>
+              <a:rPr lang="en-US" smtClean="0"/>
               <a:t>Fourth level</a:t>
             </a:r>
           </a:p>
           <a:p>
             <a:pPr lvl="4"/>
             <a:r>
-              <a:rPr lang="en-US"/>
+              <a:rPr lang="en-US" smtClean="0"/>
               <a:t>Fifth level</a:t>
             </a:r>
+            <a:endParaRPr lang="en-US"/>
           </a:p>
         </p:txBody>
       </p:sp>
@@ -661,7 +651,7 @@
           <a:p>
             <a:fld id="{5BCAD085-E8A6-8845-BD4E-CB4CCA059FC4}" type="datetimeFigureOut">
               <a:rPr lang="en-US" smtClean="0"/>
-              <a:t>10/28/2026</a:t>
+              <a:t>1/27/13</a:t>
             </a:fld>
             <a:endParaRPr lang="en-US"/>
           </a:p>
@@ -755,9 +745,10 @@
           <a:lstStyle/>
           <a:p>
             <a:r>
-              <a:rPr lang="en-US"/>
+              <a:rPr lang="en-US" smtClean="0"/>
               <a:t>Click to edit Master title style</a:t>
             </a:r>
+            <a:endParaRPr lang="en-US"/>
           </a:p>
         </p:txBody>
       </p:sp>
@@ -778,37 +769,38 @@
           <a:p>
             <a:pPr lvl="0"/>
             <a:r>
-              <a:rPr lang="en-US"/>
+              <a:rPr lang="en-US" smtClean="0"/>
               <a:t>Click to edit Master text styles</a:t>
             </a:r>
           </a:p>
           <a:p>
             <a:pPr lvl="1"/>
             <a:r>
-              <a:rPr lang="en-US"/>
+              <a:rPr lang="en-US" smtClean="0"/>
               <a:t>Second level</a:t>
             </a:r>
           </a:p>
           <a:p>
             <a:pPr lvl="2"/>
             <a:r>
-              <a:rPr lang="en-US"/>
+              <a:rPr lang="en-US" smtClean="0"/>
               <a:t>Third level</a:t>
             </a:r>
           </a:p>
           <a:p>
             <a:pPr lvl="3"/>
             <a:r>
-              <a:rPr lang="en-US"/>
+              <a:rPr lang="en-US" smtClean="0"/>
               <a:t>Fourth level</a:t>
             </a:r>
           </a:p>
           <a:p>
             <a:pPr lvl="4"/>
             <a:r>
-              <a:rPr lang="en-US"/>
+              <a:rPr lang="en-US" smtClean="0"/>
               <a:t>Fifth level</a:t>
             </a:r>
+            <a:endParaRPr lang="en-US"/>
           </a:p>
         </p:txBody>
       </p:sp>
@@ -829,7 +821,7 @@
           <a:p>
             <a:fld id="{5BCAD085-E8A6-8845-BD4E-CB4CCA059FC4}" type="datetimeFigureOut">
               <a:rPr lang="en-US" smtClean="0"/>
-              <a:t>10/28/2026</a:t>
+              <a:t>1/27/13</a:t>
             </a:fld>
             <a:endParaRPr lang="en-US"/>
           </a:p>
@@ -932,9 +924,10 @@
           </a:lstStyle>
           <a:p>
             <a:r>
-              <a:rPr lang="en-US"/>
+              <a:rPr lang="en-US" smtClean="0"/>
               <a:t>Click to edit Master title style</a:t>
             </a:r>
+            <a:endParaRPr lang="en-US"/>
           </a:p>
         </p:txBody>
       </p:sp>
@@ -1051,7 +1044,7 @@
           <a:p>
             <a:pPr lvl="0"/>
             <a:r>
-              <a:rPr lang="en-US"/>
+              <a:rPr lang="en-US" smtClean="0"/>
               <a:t>Click to edit Master text styles</a:t>
             </a:r>
           </a:p>
@@ -1074,7 +1067,7 @@
           <a:p>
             <a:fld id="{5BCAD085-E8A6-8845-BD4E-CB4CCA059FC4}" type="datetimeFigureOut">
               <a:rPr lang="en-US" smtClean="0"/>
-              <a:t>10/28/2026</a:t>
+              <a:t>1/27/13</a:t>
             </a:fld>
             <a:endParaRPr lang="en-US"/>
           </a:p>
@@ -1168,9 +1161,10 @@
           <a:lstStyle/>
           <a:p>
             <a:r>
-              <a:rPr lang="en-US"/>
+              <a:rPr lang="en-US" smtClean="0"/>
               <a:t>Click to edit Master title style</a:t>
             </a:r>
+            <a:endParaRPr lang="en-US"/>
           </a:p>
         </p:txBody>
       </p:sp>
@@ -1224,37 +1218,38 @@
           <a:p>
             <a:pPr lvl="0"/>
             <a:r>
-              <a:rPr lang="en-US"/>
+              <a:rPr lang="en-US" smtClean="0"/>
               <a:t>Click to edit Master text styles</a:t>
             </a:r>
           </a:p>
           <a:p>
             <a:pPr lvl="1"/>
             <a:r>
-              <a:rPr lang="en-US"/>
+              <a:rPr lang="en-US" smtClean="0"/>
               <a:t>Second level</a:t>
             </a:r>
           </a:p>
           <a:p>
             <a:pPr lvl="2"/>
             <a:r>
-              <a:rPr lang="en-US"/>
+              <a:rPr lang="en-US" smtClean="0"/>
               <a:t>Third level</a:t>
             </a:r>
           </a:p>
           <a:p>
             <a:pPr lvl="3"/>
             <a:r>
-              <a:rPr lang="en-US"/>
+              <a:rPr lang="en-US" smtClean="0"/>
               <a:t>Fourth level</a:t>
             </a:r>
           </a:p>
           <a:p>
             <a:pPr lvl="4"/>
             <a:r>
-              <a:rPr lang="en-US"/>
+              <a:rPr lang="en-US" smtClean="0"/>
               <a:t>Fifth level</a:t>
             </a:r>
+            <a:endParaRPr lang="en-US"/>
           </a:p>
         </p:txBody>
       </p:sp>
@@ -1308,37 +1303,38 @@
           <a:p>
             <a:pPr lvl="0"/>
             <a:r>
-              <a:rPr lang="en-US"/>
+              <a:rPr lang="en-US" smtClean="0"/>
               <a:t>Click to edit Master text styles</a:t>
             </a:r>
           </a:p>
           <a:p>
             <a:pPr lvl="1"/>
             <a:r>
-              <a:rPr lang="en-US"/>
+              <a:rPr lang="en-US" smtClean="0"/>
               <a:t>Second level</a:t>
             </a:r>
           </a:p>
           <a:p>
             <a:pPr lvl="2"/>
             <a:r>
-              <a:rPr lang="en-US"/>
+              <a:rPr lang="en-US" smtClean="0"/>
               <a:t>Third level</a:t>
             </a:r>
           </a:p>
           <a:p>
             <a:pPr lvl="3"/>
             <a:r>
-              <a:rPr lang="en-US"/>
+              <a:rPr lang="en-US" smtClean="0"/>
               <a:t>Fourth level</a:t>
             </a:r>
           </a:p>
           <a:p>
             <a:pPr lvl="4"/>
             <a:r>
-              <a:rPr lang="en-US"/>
+              <a:rPr lang="en-US" smtClean="0"/>
               <a:t>Fifth level</a:t>
             </a:r>
+            <a:endParaRPr lang="en-US"/>
           </a:p>
         </p:txBody>
       </p:sp>
@@ -1359,7 +1355,7 @@
           <a:p>
             <a:fld id="{5BCAD085-E8A6-8845-BD4E-CB4CCA059FC4}" type="datetimeFigureOut">
               <a:rPr lang="en-US" smtClean="0"/>
-              <a:t>10/28/2026</a:t>
+              <a:t>1/27/13</a:t>
             </a:fld>
             <a:endParaRPr lang="en-US"/>
           </a:p>
@@ -1457,9 +1453,10 @@
           </a:lstStyle>
           <a:p>
             <a:r>
-              <a:rPr lang="en-US"/>
+              <a:rPr lang="en-US" smtClean="0"/>
               <a:t>Click to edit Master title style</a:t>
             </a:r>
+            <a:endParaRPr lang="en-US"/>
           </a:p>
         </p:txBody>
       </p:sp>
@@ -1522,7 +1519,7 @@
           <a:p>
             <a:pPr lvl="0"/>
             <a:r>
-              <a:rPr lang="en-US"/>
+              <a:rPr lang="en-US" smtClean="0"/>
               <a:t>Click to edit Master text styles</a:t>
             </a:r>
           </a:p>
@@ -1578,37 +1575,38 @@
           <a:p>
             <a:pPr lvl="0"/>
             <a:r>
-              <a:rPr lang="en-US"/>
+              <a:rPr lang="en-US" smtClean="0"/>
               <a:t>Click to edit Master text styles</a:t>
             </a:r>
           </a:p>
           <a:p>
             <a:pPr lvl="1"/>
             <a:r>
-              <a:rPr lang="en-US"/>
+              <a:rPr lang="en-US" smtClean="0"/>
               <a:t>Second level</a:t>
             </a:r>
           </a:p>
           <a:p>
             <a:pPr lvl="2"/>
             <a:r>
-              <a:rPr lang="en-US"/>
+              <a:rPr lang="en-US" smtClean="0"/>
               <a:t>Third level</a:t>
             </a:r>
           </a:p>
           <a:p>
             <a:pPr lvl="3"/>
             <a:r>
-              <a:rPr lang="en-US"/>
+              <a:rPr lang="en-US" smtClean="0"/>
               <a:t>Fourth level</a:t>
             </a:r>
           </a:p>
           <a:p>
             <a:pPr lvl="4"/>
             <a:r>
-              <a:rPr lang="en-US"/>
+              <a:rPr lang="en-US" smtClean="0"/>
               <a:t>Fifth level</a:t>
             </a:r>
+            <a:endParaRPr lang="en-US"/>
           </a:p>
         </p:txBody>
       </p:sp>
@@ -1671,7 +1669,7 @@
           <a:p>
             <a:pPr lvl="0"/>
             <a:r>
-              <a:rPr lang="en-US"/>
+              <a:rPr lang="en-US" smtClean="0"/>
               <a:t>Click to edit Master text styles</a:t>
             </a:r>
           </a:p>
@@ -1727,37 +1725,38 @@
           <a:p>
             <a:pPr lvl="0"/>
             <a:r>
-              <a:rPr lang="en-US"/>
+              <a:rPr lang="en-US" smtClean="0"/>
               <a:t>Click to edit Master text styles</a:t>
             </a:r>
           </a:p>
           <a:p>
             <a:pPr lvl="1"/>
             <a:r>
-              <a:rPr lang="en-US"/>
+              <a:rPr lang="en-US" smtClean="0"/>
               <a:t>Second level</a:t>
             </a:r>
           </a:p>
           <a:p>
             <a:pPr lvl="2"/>
             <a:r>
-              <a:rPr lang="en-US"/>
+              <a:rPr lang="en-US" smtClean="0"/>
               <a:t>Third level</a:t>
             </a:r>
           </a:p>
           <a:p>
             <a:pPr lvl="3"/>
             <a:r>
-              <a:rPr lang="en-US"/>
+              <a:rPr lang="en-US" smtClean="0"/>
               <a:t>Fourth level</a:t>
             </a:r>
           </a:p>
           <a:p>
             <a:pPr lvl="4"/>
             <a:r>
-              <a:rPr lang="en-US"/>
+              <a:rPr lang="en-US" smtClean="0"/>
               <a:t>Fifth level</a:t>
             </a:r>
+            <a:endParaRPr lang="en-US"/>
           </a:p>
         </p:txBody>
       </p:sp>
@@ -1778,7 +1777,7 @@
           <a:p>
             <a:fld id="{5BCAD085-E8A6-8845-BD4E-CB4CCA059FC4}" type="datetimeFigureOut">
               <a:rPr lang="en-US" smtClean="0"/>
-              <a:t>10/28/2026</a:t>
+              <a:t>1/27/13</a:t>
             </a:fld>
             <a:endParaRPr lang="en-US"/>
           </a:p>
@@ -1872,9 +1871,10 @@
           <a:lstStyle/>
           <a:p>
             <a:r>
-              <a:rPr lang="en-US"/>
+              <a:rPr lang="en-US" smtClean="0"/>
               <a:t>Click to edit Master title style</a:t>
             </a:r>
+            <a:endParaRPr lang="en-US"/>
           </a:p>
         </p:txBody>
       </p:sp>
@@ -1895,7 +1895,7 @@
           <a:p>
             <a:fld id="{5BCAD085-E8A6-8845-BD4E-CB4CCA059FC4}" type="datetimeFigureOut">
               <a:rPr lang="en-US" smtClean="0"/>
-              <a:t>10/28/2026</a:t>
+              <a:t>1/27/13</a:t>
             </a:fld>
             <a:endParaRPr lang="en-US"/>
           </a:p>
@@ -1990,7 +1990,7 @@
           <a:p>
             <a:fld id="{5BCAD085-E8A6-8845-BD4E-CB4CCA059FC4}" type="datetimeFigureOut">
               <a:rPr lang="en-US" smtClean="0"/>
-              <a:t>10/28/2026</a:t>
+              <a:t>1/27/13</a:t>
             </a:fld>
             <a:endParaRPr lang="en-US"/>
           </a:p>
@@ -2093,9 +2093,10 @@
           </a:lstStyle>
           <a:p>
             <a:r>
-              <a:rPr lang="en-US"/>
+              <a:rPr lang="en-US" smtClean="0"/>
               <a:t>Click to edit Master title style</a:t>
             </a:r>
+            <a:endParaRPr lang="en-US"/>
           </a:p>
         </p:txBody>
       </p:sp>
@@ -2149,37 +2150,38 @@
           <a:p>
             <a:pPr lvl="0"/>
             <a:r>
-              <a:rPr lang="en-US"/>
+              <a:rPr lang="en-US" smtClean="0"/>
               <a:t>Click to edit Master text styles</a:t>
             </a:r>
           </a:p>
           <a:p>
             <a:pPr lvl="1"/>
             <a:r>
-              <a:rPr lang="en-US"/>
+              <a:rPr lang="en-US" smtClean="0"/>
               <a:t>Second level</a:t>
             </a:r>
           </a:p>
           <a:p>
             <a:pPr lvl="2"/>
             <a:r>
-              <a:rPr lang="en-US"/>
+              <a:rPr lang="en-US" smtClean="0"/>
               <a:t>Third level</a:t>
             </a:r>
           </a:p>
           <a:p>
             <a:pPr lvl="3"/>
             <a:r>
-              <a:rPr lang="en-US"/>
+              <a:rPr lang="en-US" smtClean="0"/>
               <a:t>Fourth level</a:t>
             </a:r>
           </a:p>
           <a:p>
             <a:pPr lvl="4"/>
             <a:r>
-              <a:rPr lang="en-US"/>
+              <a:rPr lang="en-US" smtClean="0"/>
               <a:t>Fifth level</a:t>
             </a:r>
+            <a:endParaRPr lang="en-US"/>
           </a:p>
         </p:txBody>
       </p:sp>
@@ -2242,7 +2244,7 @@
           <a:p>
             <a:pPr lvl="0"/>
             <a:r>
-              <a:rPr lang="en-US"/>
+              <a:rPr lang="en-US" smtClean="0"/>
               <a:t>Click to edit Master text styles</a:t>
             </a:r>
           </a:p>
@@ -2265,7 +2267,7 @@
           <a:p>
             <a:fld id="{5BCAD085-E8A6-8845-BD4E-CB4CCA059FC4}" type="datetimeFigureOut">
               <a:rPr lang="en-US" smtClean="0"/>
-              <a:t>10/28/2026</a:t>
+              <a:t>1/27/13</a:t>
             </a:fld>
             <a:endParaRPr lang="en-US"/>
           </a:p>
@@ -2368,9 +2370,10 @@
           </a:lstStyle>
           <a:p>
             <a:r>
-              <a:rPr lang="en-US"/>
+              <a:rPr lang="en-US" smtClean="0"/>
               <a:t>Click to edit Master title style</a:t>
             </a:r>
+            <a:endParaRPr lang="en-US"/>
           </a:p>
         </p:txBody>
       </p:sp>
@@ -2494,7 +2497,7 @@
           <a:p>
             <a:pPr lvl="0"/>
             <a:r>
-              <a:rPr lang="en-US"/>
+              <a:rPr lang="en-US" smtClean="0"/>
               <a:t>Click to edit Master text styles</a:t>
             </a:r>
           </a:p>
@@ -2517,7 +2520,7 @@
           <a:p>
             <a:fld id="{5BCAD085-E8A6-8845-BD4E-CB4CCA059FC4}" type="datetimeFigureOut">
               <a:rPr lang="en-US" smtClean="0"/>
-              <a:t>10/28/2026</a:t>
+              <a:t>1/27/13</a:t>
             </a:fld>
             <a:endParaRPr lang="en-US"/>
           </a:p>
@@ -2626,9 +2629,10 @@
           <a:lstStyle/>
           <a:p>
             <a:r>
-              <a:rPr lang="en-US"/>
+              <a:rPr lang="en-US" smtClean="0"/>
               <a:t>Click to edit Master title style</a:t>
             </a:r>
+            <a:endParaRPr lang="en-US"/>
           </a:p>
         </p:txBody>
       </p:sp>
@@ -2659,37 +2663,38 @@
           <a:p>
             <a:pPr lvl="0"/>
             <a:r>
-              <a:rPr lang="en-US"/>
+              <a:rPr lang="en-US" smtClean="0"/>
               <a:t>Click to edit Master text styles</a:t>
             </a:r>
           </a:p>
           <a:p>
             <a:pPr lvl="1"/>
             <a:r>
-              <a:rPr lang="en-US"/>
+              <a:rPr lang="en-US" smtClean="0"/>
               <a:t>Second level</a:t>
             </a:r>
           </a:p>
           <a:p>
             <a:pPr lvl="2"/>
             <a:r>
-              <a:rPr lang="en-US"/>
+              <a:rPr lang="en-US" smtClean="0"/>
               <a:t>Third level</a:t>
             </a:r>
           </a:p>
           <a:p>
             <a:pPr lvl="3"/>
             <a:r>
-              <a:rPr lang="en-US"/>
+              <a:rPr lang="en-US" smtClean="0"/>
               <a:t>Fourth level</a:t>
             </a:r>
           </a:p>
           <a:p>
             <a:pPr lvl="4"/>
             <a:r>
-              <a:rPr lang="en-US"/>
+              <a:rPr lang="en-US" smtClean="0"/>
               <a:t>Fifth level</a:t>
             </a:r>
+            <a:endParaRPr lang="en-US"/>
           </a:p>
         </p:txBody>
       </p:sp>
@@ -2728,7 +2733,7 @@
           <a:p>
             <a:fld id="{5BCAD085-E8A6-8845-BD4E-CB4CCA059FC4}" type="datetimeFigureOut">
               <a:rPr lang="en-US" smtClean="0"/>
-              <a:t>10/28/2026</a:t>
+              <a:t>1/27/13</a:t>
             </a:fld>
             <a:endParaRPr lang="en-US"/>
           </a:p>
@@ -3087,7 +3092,7 @@
 </file>
 
 <file path=ppt/slides/slide1.xml><?xml version="1.0" encoding="utf-8"?>
-<p:sld xmlns:a="http://schemas.openxmlformats.org/drawingml/2006/main" xmlns:r="http://schemas.openxmlformats.org/officeDocument/2006/relationships" xmlns:p="http://schemas.openxmlformats.org/presentationml/2006/main">
+<p:sld xmlns:a="http://schemas.openxmlformats.org/drawingml/2006/main" xmlns:p="http://schemas.openxmlformats.org/presentationml/2006/main" xmlns:r="http://schemas.openxmlformats.org/officeDocument/2006/relationships">
   <p:cSld>
     <p:spTree>
       <p:nvGrpSpPr>
@@ -3095,14 +3100,7 @@
         <p:cNvGrpSpPr/>
         <p:nvPr/>
       </p:nvGrpSpPr>
-      <p:grpSpPr>
-        <a:xfrm>
-          <a:off x="0" y="0"/>
-          <a:ext cx="0" cy="0"/>
-          <a:chOff x="0" y="0"/>
-          <a:chExt cx="0" cy="0"/>
-        </a:xfrm>
-      </p:grpSpPr>
+      <p:grpSpPr/>
       <p:sp>
         <p:nvSpPr>
           <p:cNvPr id="2" name="Rectangle 1"/>
@@ -3143,7 +3141,6 @@
           <a:lstStyle/>
           <a:p>
             <a:pPr algn="ctr"/>
-            <a:endParaRPr/>
           </a:p>
         </p:txBody>
       </p:sp>
@@ -3187,7 +3184,6 @@
           <a:lstStyle/>
           <a:p>
             <a:pPr algn="ctr"/>
-            <a:endParaRPr/>
           </a:p>
         </p:txBody>
       </p:sp>
@@ -3199,8 +3195,8 @@
         </p:nvSpPr>
         <p:spPr>
           <a:xfrm>
-            <a:off x="731520" y="1097280"/>
-            <a:ext cx="6858000" cy="4119076"/>
+            <a:off x="731520" y="822960"/>
+            <a:ext cx="6858000" cy="5303520"/>
           </a:xfrm>
           <a:prstGeom prst="rect">
             <a:avLst/>
@@ -3214,178 +3210,167 @@
           <a:lstStyle/>
           <a:p>
             <a:pPr>
-              <a:defRPr sz="1300" b="1">
+              <a:defRPr sz="1200" b="1">
                 <a:solidFill>
                   <a:srgbClr val="14B8A6"/>
                 </a:solidFill>
               </a:defRPr>
             </a:pPr>
             <a:r>
-              <a:rPr dirty="0"/>
               <a:t>BCSE308L / BCSE308P • COMPUTER NETWORKS</a:t>
             </a:r>
           </a:p>
           <a:p>
             <a:pPr>
               <a:spcBef>
-                <a:spcPts val="1000"/>
+                <a:spcPts val="600"/>
               </a:spcBef>
               <a:spcAft>
-                <a:spcPts val="2000"/>
-              </a:spcAft>
-              <a:defRPr sz="3800" b="1">
+                <a:spcPts val="1400"/>
+              </a:spcAft>
+              <a:defRPr sz="3400" b="1">
                 <a:solidFill>
                   <a:srgbClr val="FFFFFF"/>
                 </a:solidFill>
               </a:defRPr>
             </a:pPr>
             <a:r>
-              <a:rPr dirty="0"/>
               <a:t>FINAL COURSE</a:t>
             </a:r>
-            <a:br>
-              <a:rPr dirty="0"/>
-            </a:br>
-            <a:r>
-              <a:rPr dirty="0"/>
+            <a:br/>
+            <a:r>
               <a:t>PROJECT REVIEW</a:t>
             </a:r>
           </a:p>
           <a:p>
             <a:pPr>
               <a:spcAft>
-                <a:spcPts val="3000"/>
-              </a:spcAft>
-              <a:defRPr sz="1700" b="1">
+                <a:spcPts val="1800"/>
+              </a:spcAft>
+              <a:defRPr sz="1500" b="1">
                 <a:solidFill>
                   <a:srgbClr val="93C5FD"/>
                 </a:solidFill>
               </a:defRPr>
             </a:pPr>
             <a:r>
-              <a:rPr dirty="0"/>
-              <a:t>AI-Driven Digital Twin for Campus Network Failure Prediction and Autonomous SDN Remediation</a:t>
-            </a:r>
-          </a:p>
-          <a:p>
-            <a:pPr>
-              <a:spcAft>
-                <a:spcPts val="400"/>
-              </a:spcAft>
-              <a:defRPr sz="1200">
+              <a:t>Adaptive SDN Framework and AI-Driven Digital Twin for Hospital Campus Network Failure Prediction</a:t>
+            </a:r>
+          </a:p>
+          <a:p>
+            <a:pPr>
+              <a:spcAft>
+                <a:spcPts val="200"/>
+              </a:spcAft>
+              <a:defRPr sz="1100">
                 <a:solidFill>
                   <a:srgbClr val="CBD5E1"/>
                 </a:solidFill>
               </a:defRPr>
             </a:pPr>
             <a:r>
-              <a:rPr dirty="0"/>
-              <a:t>Team ID: </a:t>
-            </a:r>
-            <a:r>
-              <a:rPr lang="en-US" dirty="0"/>
-              <a:t>Three Network Tower</a:t>
-            </a:r>
-            <a:endParaRPr dirty="0"/>
-          </a:p>
-          <a:p>
-            <a:pPr>
-              <a:spcAft>
-                <a:spcPts val="400"/>
-              </a:spcAft>
-              <a:defRPr sz="1200">
+              <a:t>Team Members (Sorted on Register Number):</a:t>
+            </a:r>
+          </a:p>
+          <a:p>
+            <a:pPr>
+              <a:spcAft>
+                <a:spcPts val="200"/>
+              </a:spcAft>
+              <a:defRPr sz="1100">
                 <a:solidFill>
                   <a:srgbClr val="CBD5E1"/>
                 </a:solidFill>
               </a:defRPr>
             </a:pPr>
             <a:r>
-              <a:rPr dirty="0"/>
-              <a:t>Team Member: Parth Kashyap </a:t>
-            </a:r>
-            <a:r>
-              <a:rPr lang="en-US" dirty="0"/>
-              <a:t>[24BCE2030]</a:t>
-            </a:r>
-          </a:p>
-          <a:p>
-            <a:pPr>
-              <a:spcAft>
-                <a:spcPts val="400"/>
-              </a:spcAft>
-              <a:defRPr sz="1200">
+              <a:t>  • Kumar Aditya Raghuwanshi (24BCE0464)</a:t>
+            </a:r>
+          </a:p>
+          <a:p>
+            <a:pPr>
+              <a:spcAft>
+                <a:spcPts val="200"/>
+              </a:spcAft>
+              <a:defRPr sz="1100">
                 <a:solidFill>
                   <a:srgbClr val="CBD5E1"/>
                 </a:solidFill>
               </a:defRPr>
             </a:pPr>
             <a:r>
-              <a:rPr lang="en-US" dirty="0"/>
-              <a:t>                             Kumar Aditya Raghuvanshi[24BCE0464]</a:t>
-            </a:r>
-          </a:p>
-          <a:p>
-            <a:pPr>
-              <a:spcAft>
-                <a:spcPts val="400"/>
-              </a:spcAft>
-              <a:defRPr sz="1200">
+              <a:t>  • Parth Kashyap (24BCE2030)</a:t>
+            </a:r>
+          </a:p>
+          <a:p>
+            <a:pPr>
+              <a:spcAft>
+                <a:spcPts val="200"/>
+              </a:spcAft>
+              <a:defRPr sz="1100">
                 <a:solidFill>
                   <a:srgbClr val="CBD5E1"/>
                 </a:solidFill>
               </a:defRPr>
             </a:pPr>
             <a:r>
-              <a:rPr lang="en-US" dirty="0"/>
-              <a:t>                              </a:t>
-            </a:r>
-            <a:r>
-              <a:rPr lang="en-US" dirty="0" err="1"/>
-              <a:t>Prakrash</a:t>
-            </a:r>
-            <a:r>
-              <a:rPr lang="en-US" dirty="0"/>
-              <a:t> Pandey [24BCE2849]</a:t>
-            </a:r>
-            <a:endParaRPr dirty="0"/>
-          </a:p>
-          <a:p>
-            <a:pPr>
-              <a:spcAft>
-                <a:spcPts val="400"/>
-              </a:spcAft>
-              <a:defRPr sz="1200">
+              <a:t>  • Prakrash Pandey (24BCE2849)</a:t>
+            </a:r>
+          </a:p>
+          <a:p>
+            <a:pPr>
+              <a:spcAft>
+                <a:spcPts val="200"/>
+              </a:spcAft>
+              <a:defRPr sz="1100">
                 <a:solidFill>
                   <a:srgbClr val="CBD5E1"/>
                 </a:solidFill>
               </a:defRPr>
             </a:pPr>
-            <a:r>
-              <a:rPr dirty="0"/>
-              <a:t>Faculty Mentor: [</a:t>
-            </a:r>
-            <a:r>
-              <a:rPr lang="en-US" dirty="0"/>
-              <a:t>Yoganand S</a:t>
-            </a:r>
-            <a:r>
-              <a:rPr dirty="0"/>
-              <a:t>]</a:t>
-            </a:r>
-          </a:p>
-          <a:p>
-            <a:pPr>
-              <a:spcAft>
-                <a:spcPts val="400"/>
-              </a:spcAft>
-              <a:defRPr sz="1200">
+          </a:p>
+          <a:p>
+            <a:pPr>
+              <a:spcAft>
+                <a:spcPts val="200"/>
+              </a:spcAft>
+              <a:defRPr sz="1100">
                 <a:solidFill>
                   <a:srgbClr val="CBD5E1"/>
                 </a:solidFill>
               </a:defRPr>
             </a:pPr>
             <a:r>
-              <a:rPr dirty="0"/>
+              <a:t>Faculty Mentor: DR. YOGANAND S., Assistant Professor Senior Grade-2</a:t>
+            </a:r>
+          </a:p>
+          <a:p>
+            <a:pPr>
+              <a:spcAft>
+                <a:spcPts val="200"/>
+              </a:spcAft>
+              <a:defRPr sz="1100">
+                <a:solidFill>
+                  <a:srgbClr val="CBD5E1"/>
+                </a:solidFill>
+              </a:defRPr>
+            </a:pPr>
+            <a:r>
+              <a:t>Centre for Artificial Intelligence and Research (CFAIR), SCOPE</a:t>
+            </a:r>
+          </a:p>
+          <a:p>
+            <a:pPr>
+              <a:spcAft>
+                <a:spcPts val="200"/>
+              </a:spcAft>
+              <a:defRPr sz="1100">
+                <a:solidFill>
+                  <a:srgbClr val="CBD5E1"/>
+                </a:solidFill>
+              </a:defRPr>
+            </a:pPr>
+            <a:r>
               <a:t>Review Date: October 2026</a:t>
             </a:r>
           </a:p>
@@ -3400,7 +3385,7 @@
 </file>
 
 <file path=ppt/slides/slide10.xml><?xml version="1.0" encoding="utf-8"?>
-<p:sld xmlns:a="http://schemas.openxmlformats.org/drawingml/2006/main" xmlns:r="http://schemas.openxmlformats.org/officeDocument/2006/relationships" xmlns:p="http://schemas.openxmlformats.org/presentationml/2006/main">
+<p:sld xmlns:a="http://schemas.openxmlformats.org/drawingml/2006/main" xmlns:p="http://schemas.openxmlformats.org/presentationml/2006/main" xmlns:r="http://schemas.openxmlformats.org/officeDocument/2006/relationships">
   <p:cSld>
     <p:spTree>
       <p:nvGrpSpPr>
@@ -3408,14 +3393,7 @@
         <p:cNvGrpSpPr/>
         <p:nvPr/>
       </p:nvGrpSpPr>
-      <p:grpSpPr>
-        <a:xfrm>
-          <a:off x="0" y="0"/>
-          <a:ext cx="0" cy="0"/>
-          <a:chOff x="0" y="0"/>
-          <a:chExt cx="0" cy="0"/>
-        </a:xfrm>
-      </p:grpSpPr>
+      <p:grpSpPr/>
       <p:sp>
         <p:nvSpPr>
           <p:cNvPr id="2" name="Rectangle 1"/>
@@ -3456,7 +3434,6 @@
           <a:lstStyle/>
           <a:p>
             <a:pPr algn="ctr"/>
-            <a:endParaRPr/>
           </a:p>
         </p:txBody>
       </p:sp>
@@ -3583,7 +3560,7 @@
           </a:fontRef>
         </p:style>
         <p:txBody>
-          <a:bodyPr wrap="square" lIns="182880" tIns="164592" rIns="182880" bIns="137160" rtlCol="0" anchor="t"/>
+          <a:bodyPr rtlCol="0" anchor="t" wrap="square" lIns="182880" rIns="182880" tIns="164592" bIns="137160"/>
           <a:lstStyle/>
           <a:p>
             <a:pPr algn="ctr">
@@ -3685,7 +3662,7 @@
           </a:fontRef>
         </p:style>
         <p:txBody>
-          <a:bodyPr wrap="square" lIns="182880" tIns="164592" rIns="182880" bIns="137160" rtlCol="0" anchor="t"/>
+          <a:bodyPr rtlCol="0" anchor="t" wrap="square" lIns="182880" rIns="182880" tIns="164592" bIns="137160"/>
           <a:lstStyle/>
           <a:p>
             <a:pPr algn="ctr">
@@ -3799,34 +3776,10 @@
                 <a:tableStyleId>{5C22544A-7EE6-4342-B048-85BDC9FD1C3A}</a:tableStyleId>
               </a:tblPr>
               <a:tblGrid>
-                <a:gridCol w="2560320">
-                  <a:extLst>
-                    <a:ext uri="{9D8B030D-6E8A-4147-A177-3AD203B41FA5}">
-                      <a16:colId xmlns:a16="http://schemas.microsoft.com/office/drawing/2014/main" val="20000"/>
-                    </a:ext>
-                  </a:extLst>
-                </a:gridCol>
-                <a:gridCol w="3840480">
-                  <a:extLst>
-                    <a:ext uri="{9D8B030D-6E8A-4147-A177-3AD203B41FA5}">
-                      <a16:colId xmlns:a16="http://schemas.microsoft.com/office/drawing/2014/main" val="20001"/>
-                    </a:ext>
-                  </a:extLst>
-                </a:gridCol>
-                <a:gridCol w="1828800">
-                  <a:extLst>
-                    <a:ext uri="{9D8B030D-6E8A-4147-A177-3AD203B41FA5}">
-                      <a16:colId xmlns:a16="http://schemas.microsoft.com/office/drawing/2014/main" val="20002"/>
-                    </a:ext>
-                  </a:extLst>
-                </a:gridCol>
-                <a:gridCol w="2468880">
-                  <a:extLst>
-                    <a:ext uri="{9D8B030D-6E8A-4147-A177-3AD203B41FA5}">
-                      <a16:colId xmlns:a16="http://schemas.microsoft.com/office/drawing/2014/main" val="20003"/>
-                    </a:ext>
-                  </a:extLst>
-                </a:gridCol>
+                <a:gridCol w="2560320"/>
+                <a:gridCol w="3840480"/>
+                <a:gridCol w="2011680"/>
+                <a:gridCol w="2286000"/>
               </a:tblGrid>
               <a:tr h="512064">
                 <a:tc>
@@ -3888,7 +3841,7 @@
                         </a:defRPr>
                       </a:pPr>
                       <a:r>
-                        <a:t>Member Contribution</a:t>
+                        <a:t>Team Member Contribution</a:t>
                       </a:r>
                     </a:p>
                   </a:txBody>
@@ -3921,11 +3874,6 @@
                     </a:solidFill>
                   </a:tcPr>
                 </a:tc>
-                <a:extLst>
-                  <a:ext uri="{0D108BD9-81ED-4DB2-BD59-A6C34878D82A}">
-                    <a16:rowId xmlns:a16="http://schemas.microsoft.com/office/drawing/2014/main" val="10000"/>
-                  </a:ext>
-                </a:extLst>
               </a:tr>
               <a:tr h="512064">
                 <a:tc>
@@ -3987,7 +3935,7 @@
                         </a:defRPr>
                       </a:pPr>
                       <a:r>
-                        <a:t>Parth Kashyap</a:t>
+                        <a:t>Kumar Aditya Raghuwanshi</a:t>
                       </a:r>
                     </a:p>
                   </a:txBody>
@@ -4020,11 +3968,6 @@
                     </a:solidFill>
                   </a:tcPr>
                 </a:tc>
-                <a:extLst>
-                  <a:ext uri="{0D108BD9-81ED-4DB2-BD59-A6C34878D82A}">
-                    <a16:rowId xmlns:a16="http://schemas.microsoft.com/office/drawing/2014/main" val="10001"/>
-                  </a:ext>
-                </a:extLst>
               </a:tr>
               <a:tr h="512064">
                 <a:tc>
@@ -4119,11 +4062,6 @@
                     </a:solidFill>
                   </a:tcPr>
                 </a:tc>
-                <a:extLst>
-                  <a:ext uri="{0D108BD9-81ED-4DB2-BD59-A6C34878D82A}">
-                    <a16:rowId xmlns:a16="http://schemas.microsoft.com/office/drawing/2014/main" val="10002"/>
-                  </a:ext>
-                </a:extLst>
               </a:tr>
               <a:tr h="512064">
                 <a:tc>
@@ -4185,7 +4123,7 @@
                         </a:defRPr>
                       </a:pPr>
                       <a:r>
-                        <a:t>Parth Kashyap</a:t>
+                        <a:t>Prakrash Pandey</a:t>
                       </a:r>
                     </a:p>
                   </a:txBody>
@@ -4218,11 +4156,6 @@
                     </a:solidFill>
                   </a:tcPr>
                 </a:tc>
-                <a:extLst>
-                  <a:ext uri="{0D108BD9-81ED-4DB2-BD59-A6C34878D82A}">
-                    <a16:rowId xmlns:a16="http://schemas.microsoft.com/office/drawing/2014/main" val="10003"/>
-                  </a:ext>
-                </a:extLst>
               </a:tr>
               <a:tr h="512064">
                 <a:tc>
@@ -4284,7 +4217,7 @@
                         </a:defRPr>
                       </a:pPr>
                       <a:r>
-                        <a:t>Parth Kashyap</a:t>
+                        <a:t>All Team Members</a:t>
                       </a:r>
                     </a:p>
                   </a:txBody>
@@ -4317,11 +4250,6 @@
                     </a:solidFill>
                   </a:tcPr>
                 </a:tc>
-                <a:extLst>
-                  <a:ext uri="{0D108BD9-81ED-4DB2-BD59-A6C34878D82A}">
-                    <a16:rowId xmlns:a16="http://schemas.microsoft.com/office/drawing/2014/main" val="10004"/>
-                  </a:ext>
-                </a:extLst>
               </a:tr>
             </a:tbl>
           </a:graphicData>
@@ -4336,7 +4264,7 @@
 </file>
 
 <file path=ppt/slides/slide11.xml><?xml version="1.0" encoding="utf-8"?>
-<p:sld xmlns:a="http://schemas.openxmlformats.org/drawingml/2006/main" xmlns:r="http://schemas.openxmlformats.org/officeDocument/2006/relationships" xmlns:p="http://schemas.openxmlformats.org/presentationml/2006/main">
+<p:sld xmlns:a="http://schemas.openxmlformats.org/drawingml/2006/main" xmlns:p="http://schemas.openxmlformats.org/presentationml/2006/main" xmlns:r="http://schemas.openxmlformats.org/officeDocument/2006/relationships">
   <p:cSld>
     <p:spTree>
       <p:nvGrpSpPr>
@@ -4344,14 +4272,7 @@
         <p:cNvGrpSpPr/>
         <p:nvPr/>
       </p:nvGrpSpPr>
-      <p:grpSpPr>
-        <a:xfrm>
-          <a:off x="0" y="0"/>
-          <a:ext cx="0" cy="0"/>
-          <a:chOff x="0" y="0"/>
-          <a:chExt cx="0" cy="0"/>
-        </a:xfrm>
-      </p:grpSpPr>
+      <p:grpSpPr/>
       <p:sp>
         <p:nvSpPr>
           <p:cNvPr id="2" name="Rectangle 1"/>
@@ -4392,7 +4313,6 @@
           <a:lstStyle/>
           <a:p>
             <a:pPr algn="ctr"/>
-            <a:endParaRPr/>
           </a:p>
         </p:txBody>
       </p:sp>
@@ -4507,7 +4427,7 @@
               <a:defRPr sz="1300" b="1"/>
             </a:pPr>
             <a:r>
-              <a:t>Individual accountability</a:t>
+              <a:t>Individual accountability (Sorted on Register Number)</a:t>
             </a:r>
           </a:p>
         </p:txBody>
@@ -4522,7 +4442,7 @@
         </p:nvGraphicFramePr>
         <p:xfrm>
           <a:off x="731520" y="1645920"/>
-          <a:ext cx="10698480" cy="1645920"/>
+          <a:ext cx="10698480" cy="1828800"/>
         </p:xfrm>
         <a:graphic>
           <a:graphicData uri="http://schemas.openxmlformats.org/drawingml/2006/table">
@@ -4531,36 +4451,12 @@
                 <a:tableStyleId>{5C22544A-7EE6-4342-B048-85BDC9FD1C3A}</a:tableStyleId>
               </a:tblPr>
               <a:tblGrid>
-                <a:gridCol w="2286000">
-                  <a:extLst>
-                    <a:ext uri="{9D8B030D-6E8A-4147-A177-3AD203B41FA5}">
-                      <a16:colId xmlns:a16="http://schemas.microsoft.com/office/drawing/2014/main" val="20000"/>
-                    </a:ext>
-                  </a:extLst>
-                </a:gridCol>
-                <a:gridCol w="3200400">
-                  <a:extLst>
-                    <a:ext uri="{9D8B030D-6E8A-4147-A177-3AD203B41FA5}">
-                      <a16:colId xmlns:a16="http://schemas.microsoft.com/office/drawing/2014/main" val="20001"/>
-                    </a:ext>
-                  </a:extLst>
-                </a:gridCol>
-                <a:gridCol w="3840480">
-                  <a:extLst>
-                    <a:ext uri="{9D8B030D-6E8A-4147-A177-3AD203B41FA5}">
-                      <a16:colId xmlns:a16="http://schemas.microsoft.com/office/drawing/2014/main" val="20002"/>
-                    </a:ext>
-                  </a:extLst>
-                </a:gridCol>
-                <a:gridCol w="1371600">
-                  <a:extLst>
-                    <a:ext uri="{9D8B030D-6E8A-4147-A177-3AD203B41FA5}">
-                      <a16:colId xmlns:a16="http://schemas.microsoft.com/office/drawing/2014/main" val="20003"/>
-                    </a:ext>
-                  </a:extLst>
-                </a:gridCol>
+                <a:gridCol w="2286000"/>
+                <a:gridCol w="2926080"/>
+                <a:gridCol w="4114800"/>
+                <a:gridCol w="1371600"/>
               </a:tblGrid>
-              <a:tr h="822960">
+              <a:tr h="457200">
                 <a:tc>
                   <a:txBody>
                     <a:bodyPr/>
@@ -4574,7 +4470,7 @@
                         </a:defRPr>
                       </a:pPr>
                       <a:r>
-                        <a:t>Member / ID</a:t>
+                        <a:t>Member / Reg No</a:t>
                       </a:r>
                     </a:p>
                   </a:txBody>
@@ -4597,7 +4493,7 @@
                         </a:defRPr>
                       </a:pPr>
                       <a:r>
-                        <a:t>Responsibility</a:t>
+                        <a:t>Primary Responsibility</a:t>
                       </a:r>
                     </a:p>
                   </a:txBody>
@@ -4653,13 +4549,8 @@
                     </a:solidFill>
                   </a:tcPr>
                 </a:tc>
-                <a:extLst>
-                  <a:ext uri="{0D108BD9-81ED-4DB2-BD59-A6C34878D82A}">
-                    <a16:rowId xmlns:a16="http://schemas.microsoft.com/office/drawing/2014/main" val="10000"/>
-                  </a:ext>
-                </a:extLst>
               </a:tr>
-              <a:tr h="822960">
+              <a:tr h="457200">
                 <a:tc>
                   <a:txBody>
                     <a:bodyPr/>
@@ -4673,11 +4564,11 @@
                         </a:defRPr>
                       </a:pPr>
                       <a:r>
-                        <a:t>Parth Kashyap</a:t>
+                        <a:t>Kumar Aditya Raghuwanshi</a:t>
                       </a:r>
                       <a:br/>
                       <a:r>
-                        <a:t>[Reg No: Placeholder]</a:t>
+                        <a:t>(24BCE0464)</a:t>
                       </a:r>
                     </a:p>
                   </a:txBody>
@@ -4700,7 +4591,7 @@
                         </a:defRPr>
                       </a:pPr>
                       <a:r>
-                        <a:t>System Architecture, AI Model Design, SDN Remediation &amp; Web NOC</a:t>
+                        <a:t>Literature Review, Telemetry Schema &amp; Network Topology Dataset</a:t>
                       </a:r>
                     </a:p>
                   </a:txBody>
@@ -4723,7 +4614,7 @@
                         </a:defRPr>
                       </a:pPr>
                       <a:r>
-                        <a:t>End-to-end implementation of FTS-LSTM, MPNN, Focal Loss, Flask REST API &amp; Cytoscape Dashboard</a:t>
+                        <a:t>Engineered telemetry data generator, 30-node topology graph, and background research</a:t>
                       </a:r>
                     </a:p>
                   </a:txBody>
@@ -4746,7 +4637,7 @@
                         </a:defRPr>
                       </a:pPr>
                       <a:r>
-                        <a:t>100%</a:t>
+                        <a:t>33.3%</a:t>
                       </a:r>
                     </a:p>
                   </a:txBody>
@@ -4756,11 +4647,202 @@
                     </a:solidFill>
                   </a:tcPr>
                 </a:tc>
-                <a:extLst>
-                  <a:ext uri="{0D108BD9-81ED-4DB2-BD59-A6C34878D82A}">
-                    <a16:rowId xmlns:a16="http://schemas.microsoft.com/office/drawing/2014/main" val="10001"/>
-                  </a:ext>
-                </a:extLst>
+              </a:tr>
+              <a:tr h="457200">
+                <a:tc>
+                  <a:txBody>
+                    <a:bodyPr/>
+                    <a:lstStyle/>
+                    <a:p>
+                      <a:pPr algn="l">
+                        <a:defRPr sz="950">
+                          <a:solidFill>
+                            <a:srgbClr val="212529"/>
+                          </a:solidFill>
+                        </a:defRPr>
+                      </a:pPr>
+                      <a:r>
+                        <a:t>Parth Kashyap</a:t>
+                      </a:r>
+                      <a:br/>
+                      <a:r>
+                        <a:t>(24BCE2030)</a:t>
+                      </a:r>
+                    </a:p>
+                  </a:txBody>
+                  <a:tcPr anchor="ctr">
+                    <a:solidFill>
+                      <a:srgbClr val="F1F5F9"/>
+                    </a:solidFill>
+                  </a:tcPr>
+                </a:tc>
+                <a:tc>
+                  <a:txBody>
+                    <a:bodyPr/>
+                    <a:lstStyle/>
+                    <a:p>
+                      <a:pPr algn="l">
+                        <a:defRPr sz="950">
+                          <a:solidFill>
+                            <a:srgbClr val="212529"/>
+                          </a:solidFill>
+                        </a:defRPr>
+                      </a:pPr>
+                      <a:r>
+                        <a:t>System Architecture, AI Spatio-Temporal Model &amp; Focal Loss</a:t>
+                      </a:r>
+                    </a:p>
+                  </a:txBody>
+                  <a:tcPr anchor="ctr">
+                    <a:solidFill>
+                      <a:srgbClr val="F1F5F9"/>
+                    </a:solidFill>
+                  </a:tcPr>
+                </a:tc>
+                <a:tc>
+                  <a:txBody>
+                    <a:bodyPr/>
+                    <a:lstStyle/>
+                    <a:p>
+                      <a:pPr algn="l">
+                        <a:defRPr sz="950">
+                          <a:solidFill>
+                            <a:srgbClr val="212529"/>
+                          </a:solidFill>
+                        </a:defRPr>
+                      </a:pPr>
+                      <a:r>
+                        <a:t>Implemented FTS-LSTM, MPNN, Focal Loss optimization, and Flask REST inference pipeline</a:t>
+                      </a:r>
+                    </a:p>
+                  </a:txBody>
+                  <a:tcPr anchor="ctr">
+                    <a:solidFill>
+                      <a:srgbClr val="F1F5F9"/>
+                    </a:solidFill>
+                  </a:tcPr>
+                </a:tc>
+                <a:tc>
+                  <a:txBody>
+                    <a:bodyPr/>
+                    <a:lstStyle/>
+                    <a:p>
+                      <a:pPr algn="l">
+                        <a:defRPr sz="950">
+                          <a:solidFill>
+                            <a:srgbClr val="212529"/>
+                          </a:solidFill>
+                        </a:defRPr>
+                      </a:pPr>
+                      <a:r>
+                        <a:t>33.4%</a:t>
+                      </a:r>
+                    </a:p>
+                  </a:txBody>
+                  <a:tcPr anchor="ctr">
+                    <a:solidFill>
+                      <a:srgbClr val="F1F5F9"/>
+                    </a:solidFill>
+                  </a:tcPr>
+                </a:tc>
+              </a:tr>
+              <a:tr h="457200">
+                <a:tc>
+                  <a:txBody>
+                    <a:bodyPr/>
+                    <a:lstStyle/>
+                    <a:p>
+                      <a:pPr algn="l">
+                        <a:defRPr sz="950">
+                          <a:solidFill>
+                            <a:srgbClr val="212529"/>
+                          </a:solidFill>
+                        </a:defRPr>
+                      </a:pPr>
+                      <a:r>
+                        <a:t>Prakrash Pandey</a:t>
+                      </a:r>
+                      <a:br/>
+                      <a:r>
+                        <a:t>(24BCE2849)</a:t>
+                      </a:r>
+                    </a:p>
+                  </a:txBody>
+                  <a:tcPr anchor="ctr">
+                    <a:solidFill>
+                      <a:srgbClr val="FFFFFF"/>
+                    </a:solidFill>
+                  </a:tcPr>
+                </a:tc>
+                <a:tc>
+                  <a:txBody>
+                    <a:bodyPr/>
+                    <a:lstStyle/>
+                    <a:p>
+                      <a:pPr algn="l">
+                        <a:defRPr sz="950">
+                          <a:solidFill>
+                            <a:srgbClr val="212529"/>
+                          </a:solidFill>
+                        </a:defRPr>
+                      </a:pPr>
+                      <a:r>
+                        <a:t>Autonomous SDN Controller, Web NOC UI &amp; Scenario Testing</a:t>
+                      </a:r>
+                    </a:p>
+                  </a:txBody>
+                  <a:tcPr anchor="ctr">
+                    <a:solidFill>
+                      <a:srgbClr val="FFFFFF"/>
+                    </a:solidFill>
+                  </a:tcPr>
+                </a:tc>
+                <a:tc>
+                  <a:txBody>
+                    <a:bodyPr/>
+                    <a:lstStyle/>
+                    <a:p>
+                      <a:pPr algn="l">
+                        <a:defRPr sz="950">
+                          <a:solidFill>
+                            <a:srgbClr val="212529"/>
+                          </a:solidFill>
+                        </a:defRPr>
+                      </a:pPr>
+                      <a:r>
+                        <a:t>Developed OpenFlow remediation engine, Cytoscape/Chart.js UI, and multi-scenario validation</a:t>
+                      </a:r>
+                    </a:p>
+                  </a:txBody>
+                  <a:tcPr anchor="ctr">
+                    <a:solidFill>
+                      <a:srgbClr val="FFFFFF"/>
+                    </a:solidFill>
+                  </a:tcPr>
+                </a:tc>
+                <a:tc>
+                  <a:txBody>
+                    <a:bodyPr/>
+                    <a:lstStyle/>
+                    <a:p>
+                      <a:pPr algn="l">
+                        <a:defRPr sz="950">
+                          <a:solidFill>
+                            <a:srgbClr val="212529"/>
+                          </a:solidFill>
+                        </a:defRPr>
+                      </a:pPr>
+                      <a:r>
+                        <a:t>33.3%</a:t>
+                      </a:r>
+                    </a:p>
+                  </a:txBody>
+                  <a:tcPr anchor="ctr">
+                    <a:solidFill>
+                      <a:srgbClr val="FFFFFF"/>
+                    </a:solidFill>
+                  </a:tcPr>
+                </a:tc>
               </a:tr>
             </a:tbl>
           </a:graphicData>
@@ -4774,8 +4856,8 @@
         </p:nvSpPr>
         <p:spPr>
           <a:xfrm>
-            <a:off x="731520" y="3657600"/>
-            <a:ext cx="5120640" cy="2468880"/>
+            <a:off x="731520" y="3749039"/>
+            <a:ext cx="5120640" cy="2377440"/>
           </a:xfrm>
           <a:prstGeom prst="roundRect">
             <a:avLst/>
@@ -4804,7 +4886,7 @@
           </a:fontRef>
         </p:style>
         <p:txBody>
-          <a:bodyPr wrap="square" lIns="182880" tIns="164592" rIns="182880" bIns="137160" rtlCol="0" anchor="t"/>
+          <a:bodyPr rtlCol="0" anchor="t" wrap="square" lIns="182880" rIns="182880" tIns="164592" bIns="137160"/>
           <a:lstStyle/>
           <a:p>
             <a:pPr algn="ctr">
@@ -4906,8 +4988,8 @@
         </p:nvSpPr>
         <p:spPr>
           <a:xfrm>
-            <a:off x="6309360" y="3657600"/>
-            <a:ext cx="5120640" cy="2468880"/>
+            <a:off x="6309360" y="3749039"/>
+            <a:ext cx="5120640" cy="2377440"/>
           </a:xfrm>
           <a:prstGeom prst="roundRect">
             <a:avLst/>
@@ -4936,7 +5018,7 @@
           </a:fontRef>
         </p:style>
         <p:txBody>
-          <a:bodyPr wrap="square" lIns="182880" tIns="164592" rIns="182880" bIns="137160" rtlCol="0" anchor="t"/>
+          <a:bodyPr rtlCol="0" anchor="t" wrap="square" lIns="182880" rIns="182880" tIns="164592" bIns="137160"/>
           <a:lstStyle/>
           <a:p>
             <a:pPr algn="ctr">
@@ -4965,7 +5047,7 @@
               </a:defRPr>
             </a:pPr>
             <a:r>
-              <a:t>• Project Codebase: `c:\Users\Parth Kashyap\Desktop\cn`</a:t>
+              <a:t>• Project GitHub: https://github.com/fparth234-wq/campus-network-digital-twin</a:t>
             </a:r>
           </a:p>
           <a:p>
@@ -5039,7 +5121,7 @@
 </file>
 
 <file path=ppt/slides/slide12.xml><?xml version="1.0" encoding="utf-8"?>
-<p:sld xmlns:a="http://schemas.openxmlformats.org/drawingml/2006/main" xmlns:r="http://schemas.openxmlformats.org/officeDocument/2006/relationships" xmlns:p="http://schemas.openxmlformats.org/presentationml/2006/main">
+<p:sld xmlns:a="http://schemas.openxmlformats.org/drawingml/2006/main" xmlns:p="http://schemas.openxmlformats.org/presentationml/2006/main" xmlns:r="http://schemas.openxmlformats.org/officeDocument/2006/relationships">
   <p:cSld>
     <p:spTree>
       <p:nvGrpSpPr>
@@ -5047,14 +5129,7 @@
         <p:cNvGrpSpPr/>
         <p:nvPr/>
       </p:nvGrpSpPr>
-      <p:grpSpPr>
-        <a:xfrm>
-          <a:off x="0" y="0"/>
-          <a:ext cx="0" cy="0"/>
-          <a:chOff x="0" y="0"/>
-          <a:chExt cx="0" cy="0"/>
-        </a:xfrm>
-      </p:grpSpPr>
+      <p:grpSpPr/>
       <p:sp>
         <p:nvSpPr>
           <p:cNvPr id="2" name="Rectangle 1"/>
@@ -5095,7 +5170,6 @@
           <a:lstStyle/>
           <a:p>
             <a:pPr algn="ctr"/>
-            <a:endParaRPr/>
           </a:p>
         </p:txBody>
       </p:sp>
@@ -5222,7 +5296,7 @@
           </a:fontRef>
         </p:style>
         <p:txBody>
-          <a:bodyPr wrap="square" lIns="182880" tIns="164592" rIns="182880" bIns="137160" rtlCol="0" anchor="t"/>
+          <a:bodyPr rtlCol="0" anchor="t" wrap="square" lIns="182880" rIns="182880" tIns="164592" bIns="137160"/>
           <a:lstStyle/>
           <a:p>
             <a:pPr algn="ctr">
@@ -5324,7 +5398,7 @@
           </a:fontRef>
         </p:style>
         <p:txBody>
-          <a:bodyPr wrap="square" lIns="182880" tIns="164592" rIns="182880" bIns="137160" rtlCol="0" anchor="t"/>
+          <a:bodyPr rtlCol="0" anchor="t" wrap="square" lIns="182880" rIns="182880" tIns="164592" bIns="137160"/>
           <a:lstStyle/>
           <a:p>
             <a:pPr algn="ctr">
@@ -5353,7 +5427,7 @@
               </a:defRPr>
             </a:pPr>
             <a:r>
-              <a:t>• Graph Neural Networks (MPNN) are essential for networks because failures cascade across physical physical cabling topologies.</a:t>
+              <a:t>• Graph Neural Networks (MPNN) are essential for networks because failures cascade across physical cabling topologies.</a:t>
             </a:r>
           </a:p>
           <a:p>
@@ -5426,7 +5500,7 @@
           </a:fontRef>
         </p:style>
         <p:txBody>
-          <a:bodyPr wrap="square" lIns="182880" tIns="164592" rIns="182880" bIns="137160" rtlCol="0" anchor="t"/>
+          <a:bodyPr rtlCol="0" anchor="t" wrap="square" lIns="182880" rIns="182880" tIns="164592" bIns="137160"/>
           <a:lstStyle/>
           <a:p>
             <a:pPr algn="ctr">
@@ -5513,7 +5587,7 @@
           </a:fontRef>
         </p:style>
         <p:txBody>
-          <a:bodyPr wrap="square" lIns="182880" tIns="164592" rIns="182880" bIns="137160" rtlCol="0" anchor="t"/>
+          <a:bodyPr rtlCol="0" anchor="t" wrap="square" lIns="182880" rIns="182880" tIns="164592" bIns="137160"/>
           <a:lstStyle/>
           <a:p>
             <a:pPr algn="ctr">
@@ -5621,7 +5695,7 @@
 </file>
 
 <file path=ppt/slides/slide13.xml><?xml version="1.0" encoding="utf-8"?>
-<p:sld xmlns:a="http://schemas.openxmlformats.org/drawingml/2006/main" xmlns:r="http://schemas.openxmlformats.org/officeDocument/2006/relationships" xmlns:p="http://schemas.openxmlformats.org/presentationml/2006/main">
+<p:sld xmlns:a="http://schemas.openxmlformats.org/drawingml/2006/main" xmlns:p="http://schemas.openxmlformats.org/presentationml/2006/main" xmlns:r="http://schemas.openxmlformats.org/officeDocument/2006/relationships">
   <p:cSld>
     <p:spTree>
       <p:nvGrpSpPr>
@@ -5629,14 +5703,7 @@
         <p:cNvGrpSpPr/>
         <p:nvPr/>
       </p:nvGrpSpPr>
-      <p:grpSpPr>
-        <a:xfrm>
-          <a:off x="0" y="0"/>
-          <a:ext cx="0" cy="0"/>
-          <a:chOff x="0" y="0"/>
-          <a:chExt cx="0" cy="0"/>
-        </a:xfrm>
-      </p:grpSpPr>
+      <p:grpSpPr/>
       <p:sp>
         <p:nvSpPr>
           <p:cNvPr id="2" name="Rectangle 1"/>
@@ -5677,7 +5744,6 @@
           <a:lstStyle/>
           <a:p>
             <a:pPr algn="ctr"/>
-            <a:endParaRPr/>
           </a:p>
         </p:txBody>
       </p:sp>
@@ -5804,7 +5870,7 @@
           </a:fontRef>
         </p:style>
         <p:txBody>
-          <a:bodyPr wrap="square" lIns="182880" tIns="164592" rIns="182880" bIns="137160" rtlCol="0" anchor="t"/>
+          <a:bodyPr rtlCol="0" anchor="t" wrap="square" lIns="182880" rIns="182880" tIns="164592" bIns="137160"/>
           <a:lstStyle/>
           <a:p>
             <a:pPr algn="ctr">
@@ -5847,7 +5913,6 @@
                 </a:solidFill>
               </a:defRPr>
             </a:pPr>
-            <a:endParaRPr/>
           </a:p>
           <a:p>
             <a:pPr>
@@ -5875,7 +5940,6 @@
                 </a:solidFill>
               </a:defRPr>
             </a:pPr>
-            <a:endParaRPr/>
           </a:p>
           <a:p>
             <a:pPr>
@@ -5903,7 +5967,6 @@
                 </a:solidFill>
               </a:defRPr>
             </a:pPr>
-            <a:endParaRPr/>
           </a:p>
           <a:p>
             <a:pPr>
@@ -5931,7 +5994,6 @@
                 </a:solidFill>
               </a:defRPr>
             </a:pPr>
-            <a:endParaRPr/>
           </a:p>
           <a:p>
             <a:pPr>
@@ -5959,7 +6021,6 @@
                 </a:solidFill>
               </a:defRPr>
             </a:pPr>
-            <a:endParaRPr/>
           </a:p>
           <a:p>
             <a:pPr>
@@ -6016,7 +6077,7 @@
           </a:fontRef>
         </p:style>
         <p:txBody>
-          <a:bodyPr wrap="square" lIns="182880" tIns="164592" rIns="182880" bIns="137160" rtlCol="0" anchor="t"/>
+          <a:bodyPr rtlCol="0" anchor="t" wrap="square" lIns="182880" rIns="182880" tIns="164592" bIns="137160"/>
           <a:lstStyle/>
           <a:p>
             <a:pPr algn="ctr">
@@ -6045,7 +6106,7 @@
               </a:defRPr>
             </a:pPr>
             <a:r>
-              <a:t>• Code Repository: C:\Users\Parth Kashyap\Desktop\cn</a:t>
+              <a:t>• Code Repository: https://github.com/fparth234-wq/campus-network-digital-twin</a:t>
             </a:r>
           </a:p>
           <a:p>
@@ -6133,7 +6194,7 @@
           </a:fontRef>
         </p:style>
         <p:txBody>
-          <a:bodyPr wrap="square" lIns="182880" tIns="164592" rIns="182880" bIns="137160" rtlCol="0" anchor="t"/>
+          <a:bodyPr rtlCol="0" anchor="t" wrap="square" lIns="182880" rIns="182880" tIns="164592" bIns="137160"/>
           <a:lstStyle/>
           <a:p>
             <a:pPr algn="ctr">
@@ -6236,7 +6297,7 @@
 </file>
 
 <file path=ppt/slides/slide14.xml><?xml version="1.0" encoding="utf-8"?>
-<p:sld xmlns:a="http://schemas.openxmlformats.org/drawingml/2006/main" xmlns:r="http://schemas.openxmlformats.org/officeDocument/2006/relationships" xmlns:p="http://schemas.openxmlformats.org/presentationml/2006/main">
+<p:sld xmlns:a="http://schemas.openxmlformats.org/drawingml/2006/main" xmlns:p="http://schemas.openxmlformats.org/presentationml/2006/main" xmlns:r="http://schemas.openxmlformats.org/officeDocument/2006/relationships">
   <p:cSld>
     <p:spTree>
       <p:nvGrpSpPr>
@@ -6244,14 +6305,7 @@
         <p:cNvGrpSpPr/>
         <p:nvPr/>
       </p:nvGrpSpPr>
-      <p:grpSpPr>
-        <a:xfrm>
-          <a:off x="0" y="0"/>
-          <a:ext cx="0" cy="0"/>
-          <a:chOff x="0" y="0"/>
-          <a:chExt cx="0" cy="0"/>
-        </a:xfrm>
-      </p:grpSpPr>
+      <p:grpSpPr/>
       <p:sp>
         <p:nvSpPr>
           <p:cNvPr id="2" name="Rectangle 1"/>
@@ -6292,7 +6346,6 @@
           <a:lstStyle/>
           <a:p>
             <a:pPr algn="ctr"/>
-            <a:endParaRPr/>
           </a:p>
         </p:txBody>
       </p:sp>
@@ -6384,7 +6437,7 @@
           </a:fontRef>
         </p:style>
         <p:txBody>
-          <a:bodyPr wrap="square" lIns="182880" tIns="164592" rIns="182880" bIns="137160" rtlCol="0" anchor="t"/>
+          <a:bodyPr rtlCol="0" anchor="t" wrap="square" lIns="182880" rIns="182880" tIns="164592" bIns="137160"/>
           <a:lstStyle/>
           <a:p>
             <a:pPr algn="ctr">
@@ -6472,7 +6525,6 @@
                 </a:solidFill>
               </a:defRPr>
             </a:pPr>
-            <a:endParaRPr/>
           </a:p>
           <a:p>
             <a:pPr>
@@ -6560,7 +6612,6 @@
                 </a:solidFill>
               </a:defRPr>
             </a:pPr>
-            <a:endParaRPr/>
           </a:p>
           <a:p>
             <a:pPr>
@@ -6618,7 +6669,7 @@
 </file>
 
 <file path=ppt/slides/slide2.xml><?xml version="1.0" encoding="utf-8"?>
-<p:sld xmlns:a="http://schemas.openxmlformats.org/drawingml/2006/main" xmlns:r="http://schemas.openxmlformats.org/officeDocument/2006/relationships" xmlns:p="http://schemas.openxmlformats.org/presentationml/2006/main">
+<p:sld xmlns:a="http://schemas.openxmlformats.org/drawingml/2006/main" xmlns:p="http://schemas.openxmlformats.org/presentationml/2006/main" xmlns:r="http://schemas.openxmlformats.org/officeDocument/2006/relationships">
   <p:cSld>
     <p:spTree>
       <p:nvGrpSpPr>
@@ -6626,14 +6677,7 @@
         <p:cNvGrpSpPr/>
         <p:nvPr/>
       </p:nvGrpSpPr>
-      <p:grpSpPr>
-        <a:xfrm>
-          <a:off x="0" y="0"/>
-          <a:ext cx="0" cy="0"/>
-          <a:chOff x="0" y="0"/>
-          <a:chExt cx="0" cy="0"/>
-        </a:xfrm>
-      </p:grpSpPr>
+      <p:grpSpPr/>
       <p:sp>
         <p:nvSpPr>
           <p:cNvPr id="2" name="Rectangle 1"/>
@@ -6674,7 +6718,6 @@
           <a:lstStyle/>
           <a:p>
             <a:pPr algn="ctr"/>
-            <a:endParaRPr/>
           </a:p>
         </p:txBody>
       </p:sp>
@@ -6801,7 +6844,7 @@
           </a:fontRef>
         </p:style>
         <p:txBody>
-          <a:bodyPr wrap="square" lIns="182880" tIns="164592" rIns="182880" bIns="137160" rtlCol="0" anchor="t"/>
+          <a:bodyPr rtlCol="0" anchor="t" wrap="square" lIns="182880" rIns="182880" tIns="164592" bIns="137160"/>
           <a:lstStyle/>
           <a:p>
             <a:pPr algn="ctr">
@@ -6903,7 +6946,7 @@
           </a:fontRef>
         </p:style>
         <p:txBody>
-          <a:bodyPr wrap="square" lIns="182880" tIns="164592" rIns="182880" bIns="137160" rtlCol="0" anchor="t"/>
+          <a:bodyPr rtlCol="0" anchor="t" wrap="square" lIns="182880" rIns="182880" tIns="164592" bIns="137160"/>
           <a:lstStyle/>
           <a:p>
             <a:pPr algn="ctr">
@@ -7005,7 +7048,7 @@
           </a:fontRef>
         </p:style>
         <p:txBody>
-          <a:bodyPr wrap="square" lIns="182880" tIns="164592" rIns="182880" bIns="137160" rtlCol="0" anchor="t"/>
+          <a:bodyPr rtlCol="0" anchor="t" wrap="square" lIns="182880" rIns="182880" tIns="164592" bIns="137160"/>
           <a:lstStyle/>
           <a:p>
             <a:pPr algn="ctr">
@@ -7142,7 +7185,7 @@
           </a:fontRef>
         </p:style>
         <p:txBody>
-          <a:bodyPr wrap="square" lIns="182880" tIns="164592" rIns="182880" bIns="137160" rtlCol="0" anchor="t"/>
+          <a:bodyPr rtlCol="0" anchor="t" wrap="square" lIns="182880" rIns="182880" tIns="164592" bIns="137160"/>
           <a:lstStyle/>
           <a:p>
             <a:pPr algn="ctr">
@@ -7214,7 +7257,7 @@
           </a:fontRef>
         </p:style>
         <p:txBody>
-          <a:bodyPr wrap="square" lIns="182880" tIns="164592" rIns="182880" bIns="137160" rtlCol="0" anchor="t"/>
+          <a:bodyPr rtlCol="0" anchor="t" wrap="square" lIns="182880" rIns="182880" tIns="164592" bIns="137160"/>
           <a:lstStyle/>
           <a:p>
             <a:pPr algn="ctr">
@@ -7286,7 +7329,7 @@
           </a:fontRef>
         </p:style>
         <p:txBody>
-          <a:bodyPr wrap="square" lIns="182880" tIns="164592" rIns="182880" bIns="137160" rtlCol="0" anchor="t"/>
+          <a:bodyPr rtlCol="0" anchor="t" wrap="square" lIns="182880" rIns="182880" tIns="164592" bIns="137160"/>
           <a:lstStyle/>
           <a:p>
             <a:pPr algn="ctr">
@@ -7358,7 +7401,7 @@
           </a:fontRef>
         </p:style>
         <p:txBody>
-          <a:bodyPr wrap="square" lIns="182880" tIns="164592" rIns="182880" bIns="137160" rtlCol="0" anchor="t"/>
+          <a:bodyPr rtlCol="0" anchor="t" wrap="square" lIns="182880" rIns="182880" tIns="164592" bIns="137160"/>
           <a:lstStyle/>
           <a:p>
             <a:pPr algn="ctr">
@@ -7401,7 +7444,7 @@
 </file>
 
 <file path=ppt/slides/slide3.xml><?xml version="1.0" encoding="utf-8"?>
-<p:sld xmlns:a="http://schemas.openxmlformats.org/drawingml/2006/main" xmlns:r="http://schemas.openxmlformats.org/officeDocument/2006/relationships" xmlns:p="http://schemas.openxmlformats.org/presentationml/2006/main">
+<p:sld xmlns:a="http://schemas.openxmlformats.org/drawingml/2006/main" xmlns:p="http://schemas.openxmlformats.org/presentationml/2006/main" xmlns:r="http://schemas.openxmlformats.org/officeDocument/2006/relationships">
   <p:cSld>
     <p:spTree>
       <p:nvGrpSpPr>
@@ -7409,14 +7452,7 @@
         <p:cNvGrpSpPr/>
         <p:nvPr/>
       </p:nvGrpSpPr>
-      <p:grpSpPr>
-        <a:xfrm>
-          <a:off x="0" y="0"/>
-          <a:ext cx="0" cy="0"/>
-          <a:chOff x="0" y="0"/>
-          <a:chExt cx="0" cy="0"/>
-        </a:xfrm>
-      </p:grpSpPr>
+      <p:grpSpPr/>
       <p:sp>
         <p:nvSpPr>
           <p:cNvPr id="2" name="Rectangle 1"/>
@@ -7457,7 +7493,6 @@
           <a:lstStyle/>
           <a:p>
             <a:pPr algn="ctr"/>
-            <a:endParaRPr/>
           </a:p>
         </p:txBody>
       </p:sp>
@@ -7584,7 +7619,7 @@
           </a:fontRef>
         </p:style>
         <p:txBody>
-          <a:bodyPr wrap="square" lIns="182880" tIns="164592" rIns="182880" bIns="137160" rtlCol="0" anchor="t"/>
+          <a:bodyPr rtlCol="0" anchor="t" wrap="square" lIns="182880" rIns="182880" tIns="164592" bIns="137160"/>
           <a:lstStyle/>
           <a:p>
             <a:pPr algn="ctr">
@@ -7686,7 +7721,7 @@
           </a:fontRef>
         </p:style>
         <p:txBody>
-          <a:bodyPr wrap="square" lIns="182880" tIns="164592" rIns="182880" bIns="137160" rtlCol="0" anchor="t"/>
+          <a:bodyPr rtlCol="0" anchor="t" wrap="square" lIns="182880" rIns="182880" tIns="164592" bIns="137160"/>
           <a:lstStyle/>
           <a:p>
             <a:pPr algn="ctr">
@@ -7803,7 +7838,7 @@
           </a:fontRef>
         </p:style>
         <p:txBody>
-          <a:bodyPr wrap="square" lIns="182880" tIns="164592" rIns="182880" bIns="137160" rtlCol="0" anchor="t"/>
+          <a:bodyPr rtlCol="0" anchor="t" wrap="square" lIns="182880" rIns="182880" tIns="164592" bIns="137160"/>
           <a:lstStyle/>
           <a:p>
             <a:pPr algn="ctr">
@@ -7905,7 +7940,7 @@
           </a:fontRef>
         </p:style>
         <p:txBody>
-          <a:bodyPr wrap="square" lIns="182880" tIns="164592" rIns="182880" bIns="137160" rtlCol="0" anchor="t"/>
+          <a:bodyPr rtlCol="0" anchor="t" wrap="square" lIns="182880" rIns="182880" tIns="164592" bIns="137160"/>
           <a:lstStyle/>
           <a:p>
             <a:pPr algn="ctr">
@@ -7993,7 +8028,7 @@
 </file>
 
 <file path=ppt/slides/slide4.xml><?xml version="1.0" encoding="utf-8"?>
-<p:sld xmlns:a="http://schemas.openxmlformats.org/drawingml/2006/main" xmlns:r="http://schemas.openxmlformats.org/officeDocument/2006/relationships" xmlns:p="http://schemas.openxmlformats.org/presentationml/2006/main">
+<p:sld xmlns:a="http://schemas.openxmlformats.org/drawingml/2006/main" xmlns:p="http://schemas.openxmlformats.org/presentationml/2006/main" xmlns:r="http://schemas.openxmlformats.org/officeDocument/2006/relationships">
   <p:cSld>
     <p:spTree>
       <p:nvGrpSpPr>
@@ -8001,14 +8036,7 @@
         <p:cNvGrpSpPr/>
         <p:nvPr/>
       </p:nvGrpSpPr>
-      <p:grpSpPr>
-        <a:xfrm>
-          <a:off x="0" y="0"/>
-          <a:ext cx="0" cy="0"/>
-          <a:chOff x="0" y="0"/>
-          <a:chExt cx="0" cy="0"/>
-        </a:xfrm>
-      </p:grpSpPr>
+      <p:grpSpPr/>
       <p:sp>
         <p:nvSpPr>
           <p:cNvPr id="2" name="Rectangle 1"/>
@@ -8049,7 +8077,6 @@
           <a:lstStyle/>
           <a:p>
             <a:pPr algn="ctr"/>
-            <a:endParaRPr/>
           </a:p>
         </p:txBody>
       </p:sp>
@@ -8176,7 +8203,7 @@
           </a:fontRef>
         </p:style>
         <p:txBody>
-          <a:bodyPr wrap="square" lIns="182880" tIns="164592" rIns="182880" bIns="137160" rtlCol="0" anchor="t"/>
+          <a:bodyPr rtlCol="0" anchor="t" wrap="square" lIns="182880" rIns="182880" tIns="164592" bIns="137160"/>
           <a:lstStyle/>
           <a:p>
             <a:pPr algn="ctr">
@@ -8278,7 +8305,7 @@
           </a:fontRef>
         </p:style>
         <p:txBody>
-          <a:bodyPr wrap="square" lIns="182880" tIns="164592" rIns="182880" bIns="137160" rtlCol="0" anchor="t"/>
+          <a:bodyPr rtlCol="0" anchor="t" wrap="square" lIns="182880" rIns="182880" tIns="164592" bIns="137160"/>
           <a:lstStyle/>
           <a:p>
             <a:pPr algn="ctr">
@@ -8392,34 +8419,10 @@
                 <a:tableStyleId>{5C22544A-7EE6-4342-B048-85BDC9FD1C3A}</a:tableStyleId>
               </a:tblPr>
               <a:tblGrid>
-                <a:gridCol w="2286000">
-                  <a:extLst>
-                    <a:ext uri="{9D8B030D-6E8A-4147-A177-3AD203B41FA5}">
-                      <a16:colId xmlns:a16="http://schemas.microsoft.com/office/drawing/2014/main" val="20000"/>
-                    </a:ext>
-                  </a:extLst>
-                </a:gridCol>
-                <a:gridCol w="2651760">
-                  <a:extLst>
-                    <a:ext uri="{9D8B030D-6E8A-4147-A177-3AD203B41FA5}">
-                      <a16:colId xmlns:a16="http://schemas.microsoft.com/office/drawing/2014/main" val="20001"/>
-                    </a:ext>
-                  </a:extLst>
-                </a:gridCol>
-                <a:gridCol w="2834640">
-                  <a:extLst>
-                    <a:ext uri="{9D8B030D-6E8A-4147-A177-3AD203B41FA5}">
-                      <a16:colId xmlns:a16="http://schemas.microsoft.com/office/drawing/2014/main" val="20002"/>
-                    </a:ext>
-                  </a:extLst>
-                </a:gridCol>
-                <a:gridCol w="2926080">
-                  <a:extLst>
-                    <a:ext uri="{9D8B030D-6E8A-4147-A177-3AD203B41FA5}">
-                      <a16:colId xmlns:a16="http://schemas.microsoft.com/office/drawing/2014/main" val="20003"/>
-                    </a:ext>
-                  </a:extLst>
-                </a:gridCol>
+                <a:gridCol w="2286000"/>
+                <a:gridCol w="2651760"/>
+                <a:gridCol w="2834640"/>
+                <a:gridCol w="2926080"/>
               </a:tblGrid>
               <a:tr h="512064">
                 <a:tc>
@@ -8514,11 +8517,6 @@
                     </a:solidFill>
                   </a:tcPr>
                 </a:tc>
-                <a:extLst>
-                  <a:ext uri="{0D108BD9-81ED-4DB2-BD59-A6C34878D82A}">
-                    <a16:rowId xmlns:a16="http://schemas.microsoft.com/office/drawing/2014/main" val="10000"/>
-                  </a:ext>
-                </a:extLst>
               </a:tr>
               <a:tr h="512064">
                 <a:tc>
@@ -8613,11 +8611,6 @@
                     </a:solidFill>
                   </a:tcPr>
                 </a:tc>
-                <a:extLst>
-                  <a:ext uri="{0D108BD9-81ED-4DB2-BD59-A6C34878D82A}">
-                    <a16:rowId xmlns:a16="http://schemas.microsoft.com/office/drawing/2014/main" val="10001"/>
-                  </a:ext>
-                </a:extLst>
               </a:tr>
               <a:tr h="512064">
                 <a:tc>
@@ -8712,11 +8705,6 @@
                     </a:solidFill>
                   </a:tcPr>
                 </a:tc>
-                <a:extLst>
-                  <a:ext uri="{0D108BD9-81ED-4DB2-BD59-A6C34878D82A}">
-                    <a16:rowId xmlns:a16="http://schemas.microsoft.com/office/drawing/2014/main" val="10002"/>
-                  </a:ext>
-                </a:extLst>
               </a:tr>
               <a:tr h="512064">
                 <a:tc>
@@ -8811,11 +8799,6 @@
                     </a:solidFill>
                   </a:tcPr>
                 </a:tc>
-                <a:extLst>
-                  <a:ext uri="{0D108BD9-81ED-4DB2-BD59-A6C34878D82A}">
-                    <a16:rowId xmlns:a16="http://schemas.microsoft.com/office/drawing/2014/main" val="10003"/>
-                  </a:ext>
-                </a:extLst>
               </a:tr>
               <a:tr h="512064">
                 <a:tc>
@@ -8910,11 +8893,6 @@
                     </a:solidFill>
                   </a:tcPr>
                 </a:tc>
-                <a:extLst>
-                  <a:ext uri="{0D108BD9-81ED-4DB2-BD59-A6C34878D82A}">
-                    <a16:rowId xmlns:a16="http://schemas.microsoft.com/office/drawing/2014/main" val="10004"/>
-                  </a:ext>
-                </a:extLst>
               </a:tr>
             </a:tbl>
           </a:graphicData>
@@ -8929,7 +8907,7 @@
 </file>
 
 <file path=ppt/slides/slide5.xml><?xml version="1.0" encoding="utf-8"?>
-<p:sld xmlns:a="http://schemas.openxmlformats.org/drawingml/2006/main" xmlns:r="http://schemas.openxmlformats.org/officeDocument/2006/relationships" xmlns:p="http://schemas.openxmlformats.org/presentationml/2006/main">
+<p:sld xmlns:a="http://schemas.openxmlformats.org/drawingml/2006/main" xmlns:p="http://schemas.openxmlformats.org/presentationml/2006/main" xmlns:r="http://schemas.openxmlformats.org/officeDocument/2006/relationships">
   <p:cSld>
     <p:spTree>
       <p:nvGrpSpPr>
@@ -8937,14 +8915,7 @@
         <p:cNvGrpSpPr/>
         <p:nvPr/>
       </p:nvGrpSpPr>
-      <p:grpSpPr>
-        <a:xfrm>
-          <a:off x="0" y="0"/>
-          <a:ext cx="0" cy="0"/>
-          <a:chOff x="0" y="0"/>
-          <a:chExt cx="0" cy="0"/>
-        </a:xfrm>
-      </p:grpSpPr>
+      <p:grpSpPr/>
       <p:sp>
         <p:nvSpPr>
           <p:cNvPr id="2" name="Rectangle 1"/>
@@ -8985,7 +8956,6 @@
           <a:lstStyle/>
           <a:p>
             <a:pPr algn="ctr"/>
-            <a:endParaRPr/>
           </a:p>
         </p:txBody>
       </p:sp>
@@ -9112,7 +9082,7 @@
           </a:fontRef>
         </p:style>
         <p:txBody>
-          <a:bodyPr wrap="square" lIns="182880" tIns="164592" rIns="182880" bIns="137160" rtlCol="0" anchor="t"/>
+          <a:bodyPr rtlCol="0" anchor="t" wrap="square" lIns="182880" rIns="182880" tIns="164592" bIns="137160"/>
           <a:lstStyle/>
           <a:p>
             <a:pPr algn="ctr">
@@ -9185,7 +9155,6 @@
                 </a:solidFill>
               </a:defRPr>
             </a:pPr>
-            <a:endParaRPr/>
           </a:p>
           <a:p>
             <a:pPr>
@@ -9243,7 +9212,6 @@
                 </a:solidFill>
               </a:defRPr>
             </a:pPr>
-            <a:endParaRPr/>
           </a:p>
           <a:p>
             <a:pPr>
@@ -9316,7 +9284,6 @@
                 </a:solidFill>
               </a:defRPr>
             </a:pPr>
-            <a:endParaRPr/>
           </a:p>
           <a:p>
             <a:pPr>
@@ -9403,7 +9370,7 @@
           </a:fontRef>
         </p:style>
         <p:txBody>
-          <a:bodyPr wrap="square" lIns="182880" tIns="164592" rIns="182880" bIns="137160" rtlCol="0" anchor="t"/>
+          <a:bodyPr rtlCol="0" anchor="t" wrap="square" lIns="182880" rIns="182880" tIns="164592" bIns="137160"/>
           <a:lstStyle/>
           <a:p>
             <a:pPr algn="ctr">
@@ -9520,7 +9487,7 @@
           </a:fontRef>
         </p:style>
         <p:txBody>
-          <a:bodyPr wrap="square" lIns="182880" tIns="164592" rIns="182880" bIns="137160" rtlCol="0" anchor="t"/>
+          <a:bodyPr rtlCol="0" anchor="t" wrap="square" lIns="182880" rIns="182880" tIns="164592" bIns="137160"/>
           <a:lstStyle/>
           <a:p>
             <a:pPr algn="ctr">
@@ -9607,7 +9574,7 @@
           </a:fontRef>
         </p:style>
         <p:txBody>
-          <a:bodyPr wrap="square" lIns="182880" tIns="164592" rIns="182880" bIns="137160" rtlCol="0" anchor="t"/>
+          <a:bodyPr rtlCol="0" anchor="t" wrap="square" lIns="182880" rIns="182880" tIns="164592" bIns="137160"/>
           <a:lstStyle/>
           <a:p>
             <a:pPr algn="ctr">
@@ -9680,7 +9647,7 @@
 </file>
 
 <file path=ppt/slides/slide6.xml><?xml version="1.0" encoding="utf-8"?>
-<p:sld xmlns:a="http://schemas.openxmlformats.org/drawingml/2006/main" xmlns:r="http://schemas.openxmlformats.org/officeDocument/2006/relationships" xmlns:p="http://schemas.openxmlformats.org/presentationml/2006/main">
+<p:sld xmlns:a="http://schemas.openxmlformats.org/drawingml/2006/main" xmlns:p="http://schemas.openxmlformats.org/presentationml/2006/main" xmlns:r="http://schemas.openxmlformats.org/officeDocument/2006/relationships">
   <p:cSld>
     <p:spTree>
       <p:nvGrpSpPr>
@@ -9688,14 +9655,7 @@
         <p:cNvGrpSpPr/>
         <p:nvPr/>
       </p:nvGrpSpPr>
-      <p:grpSpPr>
-        <a:xfrm>
-          <a:off x="0" y="0"/>
-          <a:ext cx="0" cy="0"/>
-          <a:chOff x="0" y="0"/>
-          <a:chExt cx="0" cy="0"/>
-        </a:xfrm>
-      </p:grpSpPr>
+      <p:grpSpPr/>
       <p:sp>
         <p:nvSpPr>
           <p:cNvPr id="2" name="Rectangle 1"/>
@@ -9736,7 +9696,6 @@
           <a:lstStyle/>
           <a:p>
             <a:pPr algn="ctr"/>
-            <a:endParaRPr/>
           </a:p>
         </p:txBody>
       </p:sp>
@@ -9863,7 +9822,7 @@
           </a:fontRef>
         </p:style>
         <p:txBody>
-          <a:bodyPr wrap="square" lIns="182880" tIns="164592" rIns="182880" bIns="137160" rtlCol="0" anchor="t"/>
+          <a:bodyPr rtlCol="0" anchor="t" wrap="square" lIns="182880" rIns="182880" tIns="164592" bIns="137160"/>
           <a:lstStyle/>
           <a:p>
             <a:pPr algn="ctr">
@@ -9995,7 +9954,7 @@
           </a:fontRef>
         </p:style>
         <p:txBody>
-          <a:bodyPr wrap="square" lIns="182880" tIns="164592" rIns="182880" bIns="137160" rtlCol="0" anchor="t"/>
+          <a:bodyPr rtlCol="0" anchor="t" wrap="square" lIns="182880" rIns="182880" tIns="164592" bIns="137160"/>
           <a:lstStyle/>
           <a:p>
             <a:pPr algn="ctr">
@@ -10127,7 +10086,7 @@
           </a:fontRef>
         </p:style>
         <p:txBody>
-          <a:bodyPr wrap="square" lIns="182880" tIns="164592" rIns="182880" bIns="137160" rtlCol="0" anchor="t"/>
+          <a:bodyPr rtlCol="0" anchor="t" wrap="square" lIns="182880" rIns="182880" tIns="164592" bIns="137160"/>
           <a:lstStyle/>
           <a:p>
             <a:pPr algn="ctr">
@@ -10244,7 +10203,7 @@
           </a:fontRef>
         </p:style>
         <p:txBody>
-          <a:bodyPr wrap="square" lIns="182880" tIns="164592" rIns="182880" bIns="137160" rtlCol="0" anchor="t"/>
+          <a:bodyPr rtlCol="0" anchor="t" wrap="square" lIns="182880" rIns="182880" tIns="164592" bIns="137160"/>
           <a:lstStyle/>
           <a:p>
             <a:pPr algn="ctr">
@@ -10332,7 +10291,7 @@
 </file>
 
 <file path=ppt/slides/slide7.xml><?xml version="1.0" encoding="utf-8"?>
-<p:sld xmlns:a="http://schemas.openxmlformats.org/drawingml/2006/main" xmlns:r="http://schemas.openxmlformats.org/officeDocument/2006/relationships" xmlns:p="http://schemas.openxmlformats.org/presentationml/2006/main">
+<p:sld xmlns:a="http://schemas.openxmlformats.org/drawingml/2006/main" xmlns:p="http://schemas.openxmlformats.org/presentationml/2006/main" xmlns:r="http://schemas.openxmlformats.org/officeDocument/2006/relationships">
   <p:cSld>
     <p:spTree>
       <p:nvGrpSpPr>
@@ -10340,14 +10299,7 @@
         <p:cNvGrpSpPr/>
         <p:nvPr/>
       </p:nvGrpSpPr>
-      <p:grpSpPr>
-        <a:xfrm>
-          <a:off x="0" y="0"/>
-          <a:ext cx="0" cy="0"/>
-          <a:chOff x="0" y="0"/>
-          <a:chExt cx="0" cy="0"/>
-        </a:xfrm>
-      </p:grpSpPr>
+      <p:grpSpPr/>
       <p:sp>
         <p:nvSpPr>
           <p:cNvPr id="2" name="Rectangle 1"/>
@@ -10388,7 +10340,6 @@
           <a:lstStyle/>
           <a:p>
             <a:pPr algn="ctr"/>
-            <a:endParaRPr/>
           </a:p>
         </p:txBody>
       </p:sp>
@@ -10486,7 +10437,7 @@
         <p:spPr>
           <a:xfrm>
             <a:off x="731520" y="1371600"/>
-            <a:ext cx="3383280" cy="2057400"/>
+            <a:ext cx="3383280" cy="1828800"/>
           </a:xfrm>
           <a:prstGeom prst="roundRect">
             <a:avLst/>
@@ -10515,7 +10466,7 @@
           </a:fontRef>
         </p:style>
         <p:txBody>
-          <a:bodyPr wrap="square" lIns="182880" tIns="164592" rIns="182880" bIns="137160" rtlCol="0" anchor="t"/>
+          <a:bodyPr rtlCol="0" anchor="t" wrap="square" lIns="182880" rIns="182880" tIns="164592" bIns="137160"/>
           <a:lstStyle/>
           <a:p>
             <a:pPr algn="ctr">
@@ -10529,24 +10480,21 @@
               </a:defRPr>
             </a:pPr>
             <a:r>
-              <a:rPr dirty="0"/>
               <a:t>TEST SCENARIOS</a:t>
             </a:r>
-            <a:endParaRPr lang="en-US" dirty="0"/>
-          </a:p>
-          <a:p>
-            <a:pPr>
-              <a:spcAft>
-                <a:spcPts val="400"/>
-              </a:spcAft>
-              <a:defRPr sz="1050">
-                <a:solidFill>
-                  <a:srgbClr val="212529"/>
-                </a:solidFill>
-              </a:defRPr>
-            </a:pPr>
-            <a:r>
-              <a:rPr lang="en-US" dirty="0"/>
+          </a:p>
+          <a:p>
+            <a:pPr>
+              <a:spcAft>
+                <a:spcPts val="400"/>
+              </a:spcAft>
+              <a:defRPr sz="1050">
+                <a:solidFill>
+                  <a:srgbClr val="212529"/>
+                </a:solidFill>
+              </a:defRPr>
+            </a:pPr>
+            <a:r>
               <a:t>• Normal Operation: Baseline traffic (15-30% load) across all 30 nodes.</a:t>
             </a:r>
           </a:p>
@@ -10562,7 +10510,6 @@
               </a:defRPr>
             </a:pPr>
             <a:r>
-              <a:rPr dirty="0"/>
               <a:t>• Uplink Congestion: Ramping load to 99% on distribution switch uplink.</a:t>
             </a:r>
           </a:p>
@@ -10578,7 +10525,6 @@
               </a:defRPr>
             </a:pPr>
             <a:r>
-              <a:rPr dirty="0"/>
               <a:t>• Hardware Degradation: Injecting CRC errors and packet drops on access port.</a:t>
             </a:r>
           </a:p>
@@ -10594,7 +10540,6 @@
               </a:defRPr>
             </a:pPr>
             <a:r>
-              <a:rPr dirty="0"/>
               <a:t>• Broadcast Storm: Simulating infinite STP loop in access tier.</a:t>
             </a:r>
           </a:p>
@@ -10638,7 +10583,7 @@
           </a:fontRef>
         </p:style>
         <p:txBody>
-          <a:bodyPr wrap="square" lIns="182880" tIns="164592" rIns="182880" bIns="137160" rtlCol="0" anchor="t"/>
+          <a:bodyPr rtlCol="0" anchor="t" wrap="square" lIns="182880" rIns="182880" tIns="164592" bIns="137160"/>
           <a:lstStyle/>
           <a:p>
             <a:pPr algn="ctr">
@@ -10740,7 +10685,7 @@
           </a:fontRef>
         </p:style>
         <p:txBody>
-          <a:bodyPr wrap="square" lIns="182880" tIns="164592" rIns="182880" bIns="137160" rtlCol="0" anchor="t"/>
+          <a:bodyPr rtlCol="0" anchor="t" wrap="square" lIns="182880" rIns="182880" tIns="164592" bIns="137160"/>
           <a:lstStyle/>
           <a:p>
             <a:pPr algn="ctr">
@@ -10812,7 +10757,7 @@
         </p:nvSpPr>
         <p:spPr>
           <a:xfrm>
-            <a:off x="731520" y="3383280"/>
+            <a:off x="731520" y="3291840"/>
             <a:ext cx="10698480" cy="274320"/>
           </a:xfrm>
           <a:prstGeom prst="rect">
@@ -10854,41 +10799,11 @@
                 <a:tableStyleId>{5C22544A-7EE6-4342-B048-85BDC9FD1C3A}</a:tableStyleId>
               </a:tblPr>
               <a:tblGrid>
-                <a:gridCol w="1097280">
-                  <a:extLst>
-                    <a:ext uri="{9D8B030D-6E8A-4147-A177-3AD203B41FA5}">
-                      <a16:colId xmlns:a16="http://schemas.microsoft.com/office/drawing/2014/main" val="20000"/>
-                    </a:ext>
-                  </a:extLst>
-                </a:gridCol>
-                <a:gridCol w="2926080">
-                  <a:extLst>
-                    <a:ext uri="{9D8B030D-6E8A-4147-A177-3AD203B41FA5}">
-                      <a16:colId xmlns:a16="http://schemas.microsoft.com/office/drawing/2014/main" val="20001"/>
-                    </a:ext>
-                  </a:extLst>
-                </a:gridCol>
-                <a:gridCol w="2743200">
-                  <a:extLst>
-                    <a:ext uri="{9D8B030D-6E8A-4147-A177-3AD203B41FA5}">
-                      <a16:colId xmlns:a16="http://schemas.microsoft.com/office/drawing/2014/main" val="20002"/>
-                    </a:ext>
-                  </a:extLst>
-                </a:gridCol>
-                <a:gridCol w="2560320">
-                  <a:extLst>
-                    <a:ext uri="{9D8B030D-6E8A-4147-A177-3AD203B41FA5}">
-                      <a16:colId xmlns:a16="http://schemas.microsoft.com/office/drawing/2014/main" val="20003"/>
-                    </a:ext>
-                  </a:extLst>
-                </a:gridCol>
-                <a:gridCol w="1371600">
-                  <a:extLst>
-                    <a:ext uri="{9D8B030D-6E8A-4147-A177-3AD203B41FA5}">
-                      <a16:colId xmlns:a16="http://schemas.microsoft.com/office/drawing/2014/main" val="20004"/>
-                    </a:ext>
-                  </a:extLst>
-                </a:gridCol>
+                <a:gridCol w="1097280"/>
+                <a:gridCol w="2926080"/>
+                <a:gridCol w="2743200"/>
+                <a:gridCol w="2560320"/>
+                <a:gridCol w="1371600"/>
               </a:tblGrid>
               <a:tr h="426720">
                 <a:tc>
@@ -11006,11 +10921,6 @@
                     </a:solidFill>
                   </a:tcPr>
                 </a:tc>
-                <a:extLst>
-                  <a:ext uri="{0D108BD9-81ED-4DB2-BD59-A6C34878D82A}">
-                    <a16:rowId xmlns:a16="http://schemas.microsoft.com/office/drawing/2014/main" val="10000"/>
-                  </a:ext>
-                </a:extLst>
               </a:tr>
               <a:tr h="426720">
                 <a:tc>
@@ -11128,11 +11038,6 @@
                     </a:solidFill>
                   </a:tcPr>
                 </a:tc>
-                <a:extLst>
-                  <a:ext uri="{0D108BD9-81ED-4DB2-BD59-A6C34878D82A}">
-                    <a16:rowId xmlns:a16="http://schemas.microsoft.com/office/drawing/2014/main" val="10001"/>
-                  </a:ext>
-                </a:extLst>
               </a:tr>
               <a:tr h="426720">
                 <a:tc>
@@ -11250,11 +11155,6 @@
                     </a:solidFill>
                   </a:tcPr>
                 </a:tc>
-                <a:extLst>
-                  <a:ext uri="{0D108BD9-81ED-4DB2-BD59-A6C34878D82A}">
-                    <a16:rowId xmlns:a16="http://schemas.microsoft.com/office/drawing/2014/main" val="10002"/>
-                  </a:ext>
-                </a:extLst>
               </a:tr>
               <a:tr h="426720">
                 <a:tc>
@@ -11372,11 +11272,6 @@
                     </a:solidFill>
                   </a:tcPr>
                 </a:tc>
-                <a:extLst>
-                  <a:ext uri="{0D108BD9-81ED-4DB2-BD59-A6C34878D82A}">
-                    <a16:rowId xmlns:a16="http://schemas.microsoft.com/office/drawing/2014/main" val="10003"/>
-                  </a:ext>
-                </a:extLst>
               </a:tr>
               <a:tr h="426720">
                 <a:tc>
@@ -11494,11 +11389,6 @@
                     </a:solidFill>
                   </a:tcPr>
                 </a:tc>
-                <a:extLst>
-                  <a:ext uri="{0D108BD9-81ED-4DB2-BD59-A6C34878D82A}">
-                    <a16:rowId xmlns:a16="http://schemas.microsoft.com/office/drawing/2014/main" val="10004"/>
-                  </a:ext>
-                </a:extLst>
               </a:tr>
               <a:tr h="426720">
                 <a:tc>
@@ -11514,7 +11404,6 @@
                         </a:defRPr>
                       </a:pPr>
                       <a:r>
-                        <a:rPr dirty="0"/>
                         <a:t>T05</a:t>
                       </a:r>
                     </a:p>
@@ -11607,7 +11496,6 @@
                         </a:defRPr>
                       </a:pPr>
                       <a:r>
-                        <a:rPr dirty="0"/>
                         <a:t>PASSED (Verified)</a:t>
                       </a:r>
                     </a:p>
@@ -11618,11 +11506,6 @@
                     </a:solidFill>
                   </a:tcPr>
                 </a:tc>
-                <a:extLst>
-                  <a:ext uri="{0D108BD9-81ED-4DB2-BD59-A6C34878D82A}">
-                    <a16:rowId xmlns:a16="http://schemas.microsoft.com/office/drawing/2014/main" val="10005"/>
-                  </a:ext>
-                </a:extLst>
               </a:tr>
             </a:tbl>
           </a:graphicData>
@@ -11637,7 +11520,7 @@
 </file>
 
 <file path=ppt/slides/slide8.xml><?xml version="1.0" encoding="utf-8"?>
-<p:sld xmlns:a="http://schemas.openxmlformats.org/drawingml/2006/main" xmlns:r="http://schemas.openxmlformats.org/officeDocument/2006/relationships" xmlns:p="http://schemas.openxmlformats.org/presentationml/2006/main">
+<p:sld xmlns:a="http://schemas.openxmlformats.org/drawingml/2006/main" xmlns:p="http://schemas.openxmlformats.org/presentationml/2006/main" xmlns:r="http://schemas.openxmlformats.org/officeDocument/2006/relationships">
   <p:cSld>
     <p:spTree>
       <p:nvGrpSpPr>
@@ -11645,14 +11528,7 @@
         <p:cNvGrpSpPr/>
         <p:nvPr/>
       </p:nvGrpSpPr>
-      <p:grpSpPr>
-        <a:xfrm>
-          <a:off x="0" y="0"/>
-          <a:ext cx="0" cy="0"/>
-          <a:chOff x="0" y="0"/>
-          <a:chExt cx="0" cy="0"/>
-        </a:xfrm>
-      </p:grpSpPr>
+      <p:grpSpPr/>
       <p:sp>
         <p:nvSpPr>
           <p:cNvPr id="2" name="Rectangle 1"/>
@@ -11693,7 +11569,6 @@
           <a:lstStyle/>
           <a:p>
             <a:pPr algn="ctr"/>
-            <a:endParaRPr/>
           </a:p>
         </p:txBody>
       </p:sp>
@@ -11832,34 +11707,10 @@
                 <a:tableStyleId>{5C22544A-7EE6-4342-B048-85BDC9FD1C3A}</a:tableStyleId>
               </a:tblPr>
               <a:tblGrid>
-                <a:gridCol w="1828800">
-                  <a:extLst>
-                    <a:ext uri="{9D8B030D-6E8A-4147-A177-3AD203B41FA5}">
-                      <a16:colId xmlns:a16="http://schemas.microsoft.com/office/drawing/2014/main" val="20000"/>
-                    </a:ext>
-                  </a:extLst>
-                </a:gridCol>
-                <a:gridCol w="1371600">
-                  <a:extLst>
-                    <a:ext uri="{9D8B030D-6E8A-4147-A177-3AD203B41FA5}">
-                      <a16:colId xmlns:a16="http://schemas.microsoft.com/office/drawing/2014/main" val="20001"/>
-                    </a:ext>
-                  </a:extLst>
-                </a:gridCol>
-                <a:gridCol w="1371600">
-                  <a:extLst>
-                    <a:ext uri="{9D8B030D-6E8A-4147-A177-3AD203B41FA5}">
-                      <a16:colId xmlns:a16="http://schemas.microsoft.com/office/drawing/2014/main" val="20002"/>
-                    </a:ext>
-                  </a:extLst>
-                </a:gridCol>
-                <a:gridCol w="1097280">
-                  <a:extLst>
-                    <a:ext uri="{9D8B030D-6E8A-4147-A177-3AD203B41FA5}">
-                      <a16:colId xmlns:a16="http://schemas.microsoft.com/office/drawing/2014/main" val="20003"/>
-                    </a:ext>
-                  </a:extLst>
-                </a:gridCol>
+                <a:gridCol w="1828800"/>
+                <a:gridCol w="1371600"/>
+                <a:gridCol w="1371600"/>
+                <a:gridCol w="1097280"/>
               </a:tblGrid>
               <a:tr h="731520">
                 <a:tc>
@@ -11954,11 +11805,6 @@
                     </a:solidFill>
                   </a:tcPr>
                 </a:tc>
-                <a:extLst>
-                  <a:ext uri="{0D108BD9-81ED-4DB2-BD59-A6C34878D82A}">
-                    <a16:rowId xmlns:a16="http://schemas.microsoft.com/office/drawing/2014/main" val="10000"/>
-                  </a:ext>
-                </a:extLst>
               </a:tr>
               <a:tr h="731520">
                 <a:tc>
@@ -12053,11 +11899,6 @@
                     </a:solidFill>
                   </a:tcPr>
                 </a:tc>
-                <a:extLst>
-                  <a:ext uri="{0D108BD9-81ED-4DB2-BD59-A6C34878D82A}">
-                    <a16:rowId xmlns:a16="http://schemas.microsoft.com/office/drawing/2014/main" val="10001"/>
-                  </a:ext>
-                </a:extLst>
               </a:tr>
               <a:tr h="731520">
                 <a:tc>
@@ -12152,11 +11993,6 @@
                     </a:solidFill>
                   </a:tcPr>
                 </a:tc>
-                <a:extLst>
-                  <a:ext uri="{0D108BD9-81ED-4DB2-BD59-A6C34878D82A}">
-                    <a16:rowId xmlns:a16="http://schemas.microsoft.com/office/drawing/2014/main" val="10002"/>
-                  </a:ext>
-                </a:extLst>
               </a:tr>
               <a:tr h="731520">
                 <a:tc>
@@ -12251,11 +12087,6 @@
                     </a:solidFill>
                   </a:tcPr>
                 </a:tc>
-                <a:extLst>
-                  <a:ext uri="{0D108BD9-81ED-4DB2-BD59-A6C34878D82A}">
-                    <a16:rowId xmlns:a16="http://schemas.microsoft.com/office/drawing/2014/main" val="10003"/>
-                  </a:ext>
-                </a:extLst>
               </a:tr>
               <a:tr h="731520">
                 <a:tc>
@@ -12350,11 +12181,6 @@
                     </a:solidFill>
                   </a:tcPr>
                 </a:tc>
-                <a:extLst>
-                  <a:ext uri="{0D108BD9-81ED-4DB2-BD59-A6C34878D82A}">
-                    <a16:rowId xmlns:a16="http://schemas.microsoft.com/office/drawing/2014/main" val="10004"/>
-                  </a:ext>
-                </a:extLst>
               </a:tr>
               <a:tr h="731520">
                 <a:tc>
@@ -12449,11 +12275,6 @@
                     </a:solidFill>
                   </a:tcPr>
                 </a:tc>
-                <a:extLst>
-                  <a:ext uri="{0D108BD9-81ED-4DB2-BD59-A6C34878D82A}">
-                    <a16:rowId xmlns:a16="http://schemas.microsoft.com/office/drawing/2014/main" val="10005"/>
-                  </a:ext>
-                </a:extLst>
               </a:tr>
             </a:tbl>
           </a:graphicData>
@@ -12497,7 +12318,7 @@
           </a:fontRef>
         </p:style>
         <p:txBody>
-          <a:bodyPr wrap="square" lIns="182880" tIns="164592" rIns="182880" bIns="137160" rtlCol="0" anchor="t"/>
+          <a:bodyPr rtlCol="0" anchor="t" wrap="square" lIns="182880" rIns="182880" tIns="164592" bIns="137160"/>
           <a:lstStyle/>
           <a:p>
             <a:pPr algn="ctr">
@@ -12584,7 +12405,7 @@
           </a:fontRef>
         </p:style>
         <p:txBody>
-          <a:bodyPr wrap="square" lIns="182880" tIns="164592" rIns="182880" bIns="137160" rtlCol="0" anchor="t"/>
+          <a:bodyPr rtlCol="0" anchor="t" wrap="square" lIns="182880" rIns="182880" tIns="164592" bIns="137160"/>
           <a:lstStyle/>
           <a:p>
             <a:pPr algn="ctr">
@@ -12671,7 +12492,7 @@
           </a:fontRef>
         </p:style>
         <p:txBody>
-          <a:bodyPr wrap="square" lIns="182880" tIns="164592" rIns="182880" bIns="137160" rtlCol="0" anchor="t"/>
+          <a:bodyPr rtlCol="0" anchor="t" wrap="square" lIns="182880" rIns="182880" tIns="164592" bIns="137160"/>
           <a:lstStyle/>
           <a:p>
             <a:pPr algn="ctr">
@@ -12729,7 +12550,7 @@
 </file>
 
 <file path=ppt/slides/slide9.xml><?xml version="1.0" encoding="utf-8"?>
-<p:sld xmlns:a="http://schemas.openxmlformats.org/drawingml/2006/main" xmlns:r="http://schemas.openxmlformats.org/officeDocument/2006/relationships" xmlns:p="http://schemas.openxmlformats.org/presentationml/2006/main">
+<p:sld xmlns:a="http://schemas.openxmlformats.org/drawingml/2006/main" xmlns:p="http://schemas.openxmlformats.org/presentationml/2006/main" xmlns:r="http://schemas.openxmlformats.org/officeDocument/2006/relationships">
   <p:cSld>
     <p:spTree>
       <p:nvGrpSpPr>
@@ -12737,14 +12558,7 @@
         <p:cNvGrpSpPr/>
         <p:nvPr/>
       </p:nvGrpSpPr>
-      <p:grpSpPr>
-        <a:xfrm>
-          <a:off x="0" y="0"/>
-          <a:ext cx="0" cy="0"/>
-          <a:chOff x="0" y="0"/>
-          <a:chExt cx="0" cy="0"/>
-        </a:xfrm>
-      </p:grpSpPr>
+      <p:grpSpPr/>
       <p:sp>
         <p:nvSpPr>
           <p:cNvPr id="2" name="Rectangle 1"/>
@@ -12785,7 +12599,6 @@
           <a:lstStyle/>
           <a:p>
             <a:pPr algn="ctr"/>
-            <a:endParaRPr/>
           </a:p>
         </p:txBody>
       </p:sp>
@@ -12883,7 +12696,7 @@
         <p:spPr>
           <a:xfrm>
             <a:off x="731520" y="1371600"/>
-            <a:ext cx="6217920" cy="5029200"/>
+            <a:ext cx="6217920" cy="4846320"/>
           </a:xfrm>
           <a:prstGeom prst="roundRect">
             <a:avLst/>
@@ -12912,7 +12725,7 @@
           </a:fontRef>
         </p:style>
         <p:txBody>
-          <a:bodyPr wrap="square" lIns="182880" tIns="164592" rIns="182880" bIns="137160" rtlCol="0" anchor="t"/>
+          <a:bodyPr rtlCol="0" anchor="t" wrap="square" lIns="182880" rIns="182880" tIns="164592" bIns="137160"/>
           <a:lstStyle/>
           <a:p>
             <a:pPr algn="ctr">
@@ -12926,7 +12739,6 @@
               </a:defRPr>
             </a:pPr>
             <a:r>
-              <a:rPr dirty="0"/>
               <a:t>LIVE DEMONSTRATION WORKFLOW</a:t>
             </a:r>
           </a:p>
@@ -12942,7 +12754,6 @@
               </a:defRPr>
             </a:pPr>
             <a:r>
-              <a:rPr dirty="0"/>
               <a:t>System Demonstration Architecture (Flask Web NOC at `http://127.0.0.1:5000`):</a:t>
             </a:r>
           </a:p>
@@ -12957,21 +12768,19 @@
                 </a:solidFill>
               </a:defRPr>
             </a:pPr>
-            <a:endParaRPr dirty="0"/>
-          </a:p>
-          <a:p>
-            <a:pPr>
-              <a:spcAft>
-                <a:spcPts val="400"/>
-              </a:spcAft>
-              <a:defRPr sz="1050">
-                <a:solidFill>
-                  <a:srgbClr val="212529"/>
-                </a:solidFill>
-              </a:defRPr>
-            </a:pPr>
-            <a:r>
-              <a:rPr dirty="0"/>
+          </a:p>
+          <a:p>
+            <a:pPr>
+              <a:spcAft>
+                <a:spcPts val="400"/>
+              </a:spcAft>
+              <a:defRPr sz="1050">
+                <a:solidFill>
+                  <a:srgbClr val="212529"/>
+                </a:solidFill>
+              </a:defRPr>
+            </a:pPr>
+            <a:r>
               <a:t>1. Baseline Topology Initialization:</a:t>
             </a:r>
           </a:p>
@@ -12987,7 +12796,6 @@
               </a:defRPr>
             </a:pPr>
             <a:r>
-              <a:rPr dirty="0"/>
               <a:t>  • Cytoscape.js renders 30 switches cleanly partitioned into 7 Hospital Campus Wards (Datacenter, ICU, ER, Radiology, Surgical, Outpatient, Admin).</a:t>
             </a:r>
           </a:p>
@@ -13003,44 +12811,33 @@
               </a:defRPr>
             </a:pPr>
             <a:r>
-              <a:rPr dirty="0"/>
-              <a:t>  • Graph layout uses `</a:t>
-            </a:r>
-            <a:r>
-              <a:rPr dirty="0" err="1"/>
-              <a:t>fcose</a:t>
-            </a:r>
-            <a:r>
-              <a:rPr dirty="0"/>
-              <a:t>` compound layout to prevent clutter.</a:t>
-            </a:r>
-          </a:p>
-          <a:p>
-            <a:pPr>
-              <a:spcAft>
-                <a:spcPts val="400"/>
-              </a:spcAft>
-              <a:defRPr sz="1050">
-                <a:solidFill>
-                  <a:srgbClr val="212529"/>
-                </a:solidFill>
-              </a:defRPr>
-            </a:pPr>
-            <a:endParaRPr dirty="0"/>
-          </a:p>
-          <a:p>
-            <a:pPr>
-              <a:spcAft>
-                <a:spcPts val="400"/>
-              </a:spcAft>
-              <a:defRPr sz="1050">
-                <a:solidFill>
-                  <a:srgbClr val="212529"/>
-                </a:solidFill>
-              </a:defRPr>
-            </a:pPr>
-            <a:r>
-              <a:rPr dirty="0"/>
+              <a:t>  • Graph layout uses `fcose` compound layout to prevent clutter.</a:t>
+            </a:r>
+          </a:p>
+          <a:p>
+            <a:pPr>
+              <a:spcAft>
+                <a:spcPts val="400"/>
+              </a:spcAft>
+              <a:defRPr sz="1050">
+                <a:solidFill>
+                  <a:srgbClr val="212529"/>
+                </a:solidFill>
+              </a:defRPr>
+            </a:pPr>
+          </a:p>
+          <a:p>
+            <a:pPr>
+              <a:spcAft>
+                <a:spcPts val="400"/>
+              </a:spcAft>
+              <a:defRPr sz="1050">
+                <a:solidFill>
+                  <a:srgbClr val="212529"/>
+                </a:solidFill>
+              </a:defRPr>
+            </a:pPr>
+            <a:r>
               <a:t>2. Real-Time Telemetry Inspection (Chart.js Drawer):</a:t>
             </a:r>
           </a:p>
@@ -13056,68 +12853,48 @@
               </a:defRPr>
             </a:pPr>
             <a:r>
-              <a:rPr dirty="0"/>
-              <a:t>  • Click any node (e.g. Node 5) -&gt; </a:t>
-            </a:r>
-            <a:r>
-              <a:rPr dirty="0" err="1"/>
-              <a:t>Offcanvas</a:t>
-            </a:r>
-            <a:r>
-              <a:rPr dirty="0"/>
-              <a:t> drawer slides out.</a:t>
-            </a:r>
-          </a:p>
-          <a:p>
-            <a:pPr>
-              <a:spcAft>
-                <a:spcPts val="400"/>
-              </a:spcAft>
-              <a:defRPr sz="1050">
-                <a:solidFill>
-                  <a:srgbClr val="212529"/>
-                </a:solidFill>
-              </a:defRPr>
-            </a:pPr>
-            <a:r>
-              <a:rPr dirty="0"/>
-              <a:t>  • Displays live 15-step time-series curves: Bandwidth Load %, Buffer Queue %, Packet Drop Rate (</a:t>
-            </a:r>
-            <a:r>
-              <a:rPr dirty="0" err="1"/>
-              <a:t>pps</a:t>
-            </a:r>
-            <a:r>
-              <a:rPr dirty="0"/>
-              <a:t>), and CRC Errors.</a:t>
-            </a:r>
-          </a:p>
-          <a:p>
-            <a:pPr>
-              <a:spcAft>
-                <a:spcPts val="400"/>
-              </a:spcAft>
-              <a:defRPr sz="1050">
-                <a:solidFill>
-                  <a:srgbClr val="212529"/>
-                </a:solidFill>
-              </a:defRPr>
-            </a:pPr>
-            <a:endParaRPr dirty="0"/>
-          </a:p>
-          <a:p>
-            <a:pPr>
-              <a:spcAft>
-                <a:spcPts val="400"/>
-              </a:spcAft>
-              <a:defRPr sz="1050">
-                <a:solidFill>
-                  <a:srgbClr val="212529"/>
-                </a:solidFill>
-              </a:defRPr>
-            </a:pPr>
-            <a:r>
-              <a:rPr dirty="0"/>
+              <a:t>  • Click any node (e.g. Node 5) -&gt; Offcanvas drawer slides out.</a:t>
+            </a:r>
+          </a:p>
+          <a:p>
+            <a:pPr>
+              <a:spcAft>
+                <a:spcPts val="400"/>
+              </a:spcAft>
+              <a:defRPr sz="1050">
+                <a:solidFill>
+                  <a:srgbClr val="212529"/>
+                </a:solidFill>
+              </a:defRPr>
+            </a:pPr>
+            <a:r>
+              <a:t>  • Displays live 15-step time-series curves: Bandwidth Load %, Buffer Queue %, Packet Drop Rate (pps), and CRC Errors.</a:t>
+            </a:r>
+          </a:p>
+          <a:p>
+            <a:pPr>
+              <a:spcAft>
+                <a:spcPts val="400"/>
+              </a:spcAft>
+              <a:defRPr sz="1050">
+                <a:solidFill>
+                  <a:srgbClr val="212529"/>
+                </a:solidFill>
+              </a:defRPr>
+            </a:pPr>
+          </a:p>
+          <a:p>
+            <a:pPr>
+              <a:spcAft>
+                <a:spcPts val="400"/>
+              </a:spcAft>
+              <a:defRPr sz="1050">
+                <a:solidFill>
+                  <a:srgbClr val="212529"/>
+                </a:solidFill>
+              </a:defRPr>
+            </a:pPr>
+            <a:r>
               <a:t>3. Interactive Fault Injection Panel:</a:t>
             </a:r>
           </a:p>
@@ -13133,7 +12910,6 @@
               </a:defRPr>
             </a:pPr>
             <a:r>
-              <a:rPr dirty="0"/>
               <a:t>  • Select Node 8 -&gt; Select 'Broadcast Storm' -&gt; Click 'Simulate Fault'.</a:t>
             </a:r>
           </a:p>
@@ -13149,7 +12925,6 @@
               </a:defRPr>
             </a:pPr>
             <a:r>
-              <a:rPr dirty="0"/>
               <a:t>  • Node 8 turns RED on the topology map within 1 polling cycle.</a:t>
             </a:r>
           </a:p>
@@ -13165,7 +12940,6 @@
               </a:defRPr>
             </a:pPr>
             <a:r>
-              <a:rPr dirty="0"/>
               <a:t>  • System generates actionable alert: 'Spanning-Tree Protocol failure detected. Implement MAC-level port isolation.'</a:t>
             </a:r>
           </a:p>
@@ -13180,21 +12954,19 @@
                 </a:solidFill>
               </a:defRPr>
             </a:pPr>
-            <a:endParaRPr dirty="0"/>
-          </a:p>
-          <a:p>
-            <a:pPr>
-              <a:spcAft>
-                <a:spcPts val="400"/>
-              </a:spcAft>
-              <a:defRPr sz="1050">
-                <a:solidFill>
-                  <a:srgbClr val="212529"/>
-                </a:solidFill>
-              </a:defRPr>
-            </a:pPr>
-            <a:r>
-              <a:rPr dirty="0"/>
+          </a:p>
+          <a:p>
+            <a:pPr>
+              <a:spcAft>
+                <a:spcPts val="400"/>
+              </a:spcAft>
+              <a:defRPr sz="1050">
+                <a:solidFill>
+                  <a:srgbClr val="212529"/>
+                </a:solidFill>
+              </a:defRPr>
+            </a:pPr>
+            <a:r>
               <a:t>4. Autonomous Closed-Loop Remediation:</a:t>
             </a:r>
           </a:p>
@@ -13210,7 +12982,6 @@
               </a:defRPr>
             </a:pPr>
             <a:r>
-              <a:rPr dirty="0"/>
               <a:t>  • Click 'Apply Fix' -&gt; Controller sends OpenFlow flow-mod intent.</a:t>
             </a:r>
           </a:p>
@@ -13226,7 +12997,6 @@
               </a:defRPr>
             </a:pPr>
             <a:r>
-              <a:rPr dirty="0"/>
               <a:t>  • Activity log records rule deployment; Node 8 turns GREEN instantly.</a:t>
             </a:r>
           </a:p>
@@ -13270,7 +13040,7 @@
           </a:fontRef>
         </p:style>
         <p:txBody>
-          <a:bodyPr wrap="square" lIns="182880" tIns="164592" rIns="182880" bIns="137160" rtlCol="0" anchor="t"/>
+          <a:bodyPr rtlCol="0" anchor="t" wrap="square" lIns="182880" rIns="182880" tIns="164592" bIns="137160"/>
           <a:lstStyle/>
           <a:p>
             <a:pPr algn="ctr">
@@ -13357,7 +13127,7 @@
           </a:fontRef>
         </p:style>
         <p:txBody>
-          <a:bodyPr wrap="square" lIns="182880" tIns="164592" rIns="182880" bIns="137160" rtlCol="0" anchor="t"/>
+          <a:bodyPr rtlCol="0" anchor="t" wrap="square" lIns="182880" rIns="182880" tIns="164592" bIns="137160"/>
           <a:lstStyle/>
           <a:p>
             <a:pPr algn="ctr">

</xml_diff>